<commit_message>
Deck: "Bring Formly to T-Mobile." on the ask slide
Slide 7 headline is now the call to action; "less friction, more
switchers" moves to the speaker notes. Keeps Arjun's PowerPoint edits:
"Lets have a Race!" on slide 2 (subtitle cut), "Formly converts." on
slide 4, and the Q&A team line.

Co-Authored-By: Claude Opus 5.5 <noreply@anthropic.com>
</commit_message>
<xml_diff>
--- a/deck/Formly-deck.pptx
+++ b/deck/Formly-deck.pptx
@@ -938,7 +938,7 @@
           <a:lstStyle/>
           <a:p>
             <a:r>
-              <a:t>1:55-2:10 · Less friction, more switchers. The ask: a one-month pilot on T-Mobile's switch flow, measured on completion rate and port-in errors.</a:t>
+              <a:t>1:55-2:10 · Bring Formly to T-Mobile. Say it out loud: less friction, more switchers. The ask: a one-month pilot on T-Mobile's switch flow, measured on completion rate and port-in errors.</a:t>
             </a:r>
           </a:p>
         </p:txBody>
@@ -6882,7 +6882,7 @@
                 <a:cs typeface="Sora SemiBold"/>
                 <a:sym typeface="Sora SemiBold"/>
               </a:rPr>
-              <a:t>Less friction. More switchers.</a:t>
+              <a:t>Bring Formly to T-Mobile.</a:t>
             </a:r>
             <a:endParaRPr sz="2700" b="0">
               <a:solidFill>
@@ -7481,7 +7481,7 @@
                 <a:cs typeface="DM Sans"/>
                 <a:sym typeface="DM Sans"/>
               </a:rPr>
-              <a:t>Khangai Sukhbaatar · Salvo Bonsma · Jerry Zheng · Arjun Jindal</a:t>
+              <a:t>Khangai Sukhbaatar · Salvo Bonsma · Jerry Zheng </a:t>
             </a:r>
             <a:endParaRPr sz="900" b="0">
               <a:solidFill>
@@ -9276,7 +9276,7 @@
                 </a:solidFill>
                 <a:latin typeface="Sora SemiBold"/>
               </a:rPr>
-              <a:t>Typed forms break. Sourced forms finish.</a:t>
+              <a:t>Formly converts.</a:t>
             </a:r>
           </a:p>
         </p:txBody>
@@ -10996,7 +10996,7 @@
         </p:nvSpPr>
         <p:spPr>
           <a:xfrm>
-            <a:off x="320040" y="279400"/>
+            <a:off x="241300" y="292100"/>
             <a:ext cx="8503920" cy="508000"/>
           </a:xfrm>
           <a:prstGeom prst="rect">
@@ -11018,49 +11018,14 @@
                 </a:solidFill>
                 <a:latin typeface="Sora SemiBold"/>
               </a:rPr>
-              <a:t>Lets have a demo!</a:t>
-            </a:r>
-          </a:p>
-        </p:txBody>
-      </p:sp>
-      <p:sp>
-        <p:nvSpPr>
-          <p:cNvPr id="67" name="TextBox 66"/>
-          <p:cNvSpPr txBox="1"/>
-          <p:nvPr/>
-        </p:nvSpPr>
-        <p:spPr>
-          <a:xfrm>
-            <a:off x="320040" y="787400"/>
-            <a:ext cx="8503920" cy="304800"/>
-          </a:xfrm>
-          <a:prstGeom prst="rect">
-            <a:avLst/>
-          </a:prstGeom>
-          <a:noFill/>
-        </p:spPr>
-        <p:txBody>
-          <a:bodyPr wrap="square" anchor="t" lIns="45720" rIns="45720">
-            <a:spAutoFit/>
-          </a:bodyPr>
-          <a:lstStyle/>
-          <a:p>
-            <a:pPr algn="l"/>
-            <a:r>
-              <a:rPr sz="1400" b="0">
-                <a:solidFill>
-                  <a:srgbClr val="8A94A3"/>
-                </a:solidFill>
-                <a:latin typeface="DM Sans"/>
-              </a:rPr>
-              <a:t>Same T-Mobile sign-up, two ways. Time yourself on each.</a:t>
-            </a:r>
-          </a:p>
-        </p:txBody>
-      </p:sp>
-      <p:sp>
-        <p:nvSpPr>
-          <p:cNvPr id="68" name="Rounded Rectangle 67"/>
+              <a:t>Lets have a Race!</a:t>
+            </a:r>
+          </a:p>
+        </p:txBody>
+      </p:sp>
+      <p:sp>
+        <p:nvSpPr>
+          <p:cNvPr id="67" name="Rounded Rectangle 66"/>
           <p:cNvSpPr/>
           <p:nvPr/>
         </p:nvSpPr>
@@ -11106,7 +11071,7 @@
       </p:sp>
       <p:sp>
         <p:nvSpPr>
-          <p:cNvPr id="69" name="TextBox 68"/>
+          <p:cNvPr id="68" name="TextBox 67"/>
           <p:cNvSpPr txBox="1"/>
           <p:nvPr/>
         </p:nvSpPr>
@@ -11141,7 +11106,7 @@
       </p:sp>
       <p:sp>
         <p:nvSpPr>
-          <p:cNvPr id="70" name="TextBox 69"/>
+          <p:cNvPr id="69" name="TextBox 68"/>
           <p:cNvSpPr txBox="1"/>
           <p:nvPr/>
         </p:nvSpPr>
@@ -11176,7 +11141,7 @@
       </p:sp>
       <p:sp>
         <p:nvSpPr>
-          <p:cNvPr id="71" name="TextBox 70"/>
+          <p:cNvPr id="70" name="TextBox 69"/>
           <p:cNvSpPr txBox="1"/>
           <p:nvPr/>
         </p:nvSpPr>
@@ -11211,7 +11176,7 @@
       </p:sp>
       <p:sp>
         <p:nvSpPr>
-          <p:cNvPr id="72" name="Rounded Rectangle 71"/>
+          <p:cNvPr id="71" name="Rounded Rectangle 70"/>
           <p:cNvSpPr/>
           <p:nvPr/>
         </p:nvSpPr>
@@ -11257,7 +11222,7 @@
       </p:sp>
       <p:sp>
         <p:nvSpPr>
-          <p:cNvPr id="73" name="TextBox 72"/>
+          <p:cNvPr id="72" name="TextBox 71"/>
           <p:cNvSpPr txBox="1"/>
           <p:nvPr/>
         </p:nvSpPr>
@@ -11292,7 +11257,7 @@
       </p:sp>
       <p:sp>
         <p:nvSpPr>
-          <p:cNvPr id="74" name="TextBox 73"/>
+          <p:cNvPr id="73" name="TextBox 72"/>
           <p:cNvSpPr txBox="1"/>
           <p:nvPr/>
         </p:nvSpPr>
@@ -11327,7 +11292,7 @@
       </p:sp>
       <p:sp>
         <p:nvSpPr>
-          <p:cNvPr id="75" name="Rounded Rectangle 74"/>
+          <p:cNvPr id="74" name="Rounded Rectangle 73"/>
           <p:cNvSpPr/>
           <p:nvPr/>
         </p:nvSpPr>
@@ -11373,7 +11338,7 @@
       </p:sp>
       <p:sp>
         <p:nvSpPr>
-          <p:cNvPr id="76" name="TextBox 75"/>
+          <p:cNvPr id="75" name="TextBox 74"/>
           <p:cNvSpPr txBox="1"/>
           <p:nvPr/>
         </p:nvSpPr>
@@ -11408,7 +11373,7 @@
       </p:sp>
       <p:sp>
         <p:nvSpPr>
-          <p:cNvPr id="77" name="TextBox 76"/>
+          <p:cNvPr id="76" name="TextBox 75"/>
           <p:cNvSpPr txBox="1"/>
           <p:nvPr/>
         </p:nvSpPr>
@@ -11443,7 +11408,7 @@
       </p:sp>
       <p:sp>
         <p:nvSpPr>
-          <p:cNvPr id="78" name="TextBox 77"/>
+          <p:cNvPr id="77" name="TextBox 76"/>
           <p:cNvSpPr txBox="1"/>
           <p:nvPr/>
         </p:nvSpPr>
@@ -11478,7 +11443,7 @@
       </p:sp>
       <p:sp>
         <p:nvSpPr>
-          <p:cNvPr id="79" name="Rounded Rectangle 78"/>
+          <p:cNvPr id="78" name="Rounded Rectangle 77"/>
           <p:cNvSpPr/>
           <p:nvPr/>
         </p:nvSpPr>
@@ -11524,7 +11489,7 @@
       </p:sp>
       <p:sp>
         <p:nvSpPr>
-          <p:cNvPr id="80" name="TextBox 79"/>
+          <p:cNvPr id="79" name="TextBox 78"/>
           <p:cNvSpPr txBox="1"/>
           <p:nvPr/>
         </p:nvSpPr>
@@ -11559,7 +11524,7 @@
       </p:sp>
       <p:sp>
         <p:nvSpPr>
-          <p:cNvPr id="81" name="TextBox 80"/>
+          <p:cNvPr id="80" name="TextBox 79"/>
           <p:cNvSpPr txBox="1"/>
           <p:nvPr/>
         </p:nvSpPr>
@@ -11594,7 +11559,7 @@
       </p:sp>
       <p:sp>
         <p:nvSpPr>
-          <p:cNvPr id="82" name="TextBox 81"/>
+          <p:cNvPr id="81" name="TextBox 80"/>
           <p:cNvSpPr txBox="1"/>
           <p:nvPr/>
         </p:nvSpPr>
@@ -11629,7 +11594,7 @@
       </p:sp>
       <p:sp>
         <p:nvSpPr>
-          <p:cNvPr id="83" name="TextBox 82"/>
+          <p:cNvPr id="82" name="TextBox 81"/>
           <p:cNvSpPr txBox="1"/>
           <p:nvPr/>
         </p:nvSpPr>

</xml_diff>

<commit_message>
Deck: clean up spacing on slide 5
Field labels are larger and sit clearly above their fields, source lines
stop short so each Volt dot clears its text, and the takeaway line is
left-aligned with the rest of the slide.

Co-Authored-By: Claude Opus 5.5 <noreply@anthropic.com>
</commit_message>
<xml_diff>
--- a/deck/Formly-deck.pptx
+++ b/deck/Formly-deck.pptx
@@ -13234,8 +13234,8 @@
         </p:nvSpPr>
         <p:spPr>
           <a:xfrm>
-            <a:off x="320040" y="1303020"/>
-            <a:ext cx="3337500" cy="192000"/>
+            <a:off x="365760" y="1203960"/>
+            <a:ext cx="3337500" cy="228600"/>
           </a:xfrm>
           <a:prstGeom prst="rect">
             <a:avLst/>
@@ -13261,7 +13261,7 @@
               <a:buNone/>
             </a:pPr>
             <a:r>
-              <a:rPr lang="en" sz="825" b="0">
+              <a:rPr lang="en" sz="950" b="0">
                 <a:solidFill>
                   <a:srgbClr val="5B6575"/>
                 </a:solidFill>
@@ -13447,7 +13447,7 @@
         <p:spPr>
           <a:xfrm>
             <a:off x="3600450" y="1666494"/>
-            <a:ext cx="1851600" cy="0"/>
+            <a:ext cx="1733550" cy="0"/>
           </a:xfrm>
           <a:prstGeom prst="straightConnector1">
             <a:avLst/>
@@ -13472,8 +13472,8 @@
         </p:nvSpPr>
         <p:spPr>
           <a:xfrm>
-            <a:off x="320040" y="2023110"/>
-            <a:ext cx="3337500" cy="192000"/>
+            <a:off x="365760" y="1924050"/>
+            <a:ext cx="3337500" cy="228600"/>
           </a:xfrm>
           <a:prstGeom prst="rect">
             <a:avLst/>
@@ -13499,7 +13499,7 @@
               <a:buNone/>
             </a:pPr>
             <a:r>
-              <a:rPr lang="en" sz="825" b="0">
+              <a:rPr lang="en" sz="950" b="0">
                 <a:solidFill>
                   <a:srgbClr val="5B6575"/>
                 </a:solidFill>
@@ -13685,7 +13685,7 @@
         <p:spPr>
           <a:xfrm>
             <a:off x="3600450" y="2386584"/>
-            <a:ext cx="1851600" cy="0"/>
+            <a:ext cx="1733550" cy="0"/>
           </a:xfrm>
           <a:prstGeom prst="straightConnector1">
             <a:avLst/>
@@ -13710,8 +13710,8 @@
         </p:nvSpPr>
         <p:spPr>
           <a:xfrm>
-            <a:off x="320040" y="2743200"/>
-            <a:ext cx="3337500" cy="192000"/>
+            <a:off x="365760" y="2644140"/>
+            <a:ext cx="3337500" cy="228600"/>
           </a:xfrm>
           <a:prstGeom prst="rect">
             <a:avLst/>
@@ -13737,7 +13737,7 @@
               <a:buNone/>
             </a:pPr>
             <a:r>
-              <a:rPr lang="en" sz="825" b="0">
+              <a:rPr lang="en" sz="950" b="0">
                 <a:solidFill>
                   <a:srgbClr val="5B6575"/>
                 </a:solidFill>
@@ -13923,7 +13923,7 @@
         <p:spPr>
           <a:xfrm>
             <a:off x="3600450" y="3106674"/>
-            <a:ext cx="1851600" cy="0"/>
+            <a:ext cx="1733550" cy="0"/>
           </a:xfrm>
           <a:prstGeom prst="straightConnector1">
             <a:avLst/>
@@ -13948,8 +13948,8 @@
         </p:nvSpPr>
         <p:spPr>
           <a:xfrm>
-            <a:off x="320040" y="3463290"/>
-            <a:ext cx="3337500" cy="192000"/>
+            <a:off x="365760" y="3364230"/>
+            <a:ext cx="3337500" cy="228600"/>
           </a:xfrm>
           <a:prstGeom prst="rect">
             <a:avLst/>
@@ -13975,7 +13975,7 @@
               <a:buNone/>
             </a:pPr>
             <a:r>
-              <a:rPr lang="en" sz="825" b="0">
+              <a:rPr lang="en" sz="950" b="0">
                 <a:solidFill>
                   <a:srgbClr val="5B6575"/>
                 </a:solidFill>
@@ -14161,7 +14161,7 @@
         <p:spPr>
           <a:xfrm>
             <a:off x="3600450" y="3826764"/>
-            <a:ext cx="1851600" cy="0"/>
+            <a:ext cx="1733550" cy="0"/>
           </a:xfrm>
           <a:prstGeom prst="straightConnector1">
             <a:avLst/>
@@ -14186,8 +14186,8 @@
         </p:nvSpPr>
         <p:spPr>
           <a:xfrm>
-            <a:off x="320040" y="4354830"/>
-            <a:ext cx="8503800" cy="274200"/>
+            <a:off x="365760" y="4241800"/>
+            <a:ext cx="8382000" cy="274200"/>
           </a:xfrm>
           <a:prstGeom prst="rect">
             <a:avLst/>
@@ -14203,7 +14203,7 @@
           </a:bodyPr>
           <a:lstStyle/>
           <a:p>
-            <a:pPr indent="0" lvl="0" marL="0" rtl="0" algn="ctr">
+            <a:pPr indent="0" lvl="0" marL="0" rtl="0" algn="l">
               <a:spcBef>
                 <a:spcPts val="0"/>
               </a:spcBef>
@@ -14213,7 +14213,7 @@
               <a:buNone/>
             </a:pPr>
             <a:r>
-              <a:rPr lang="en" sz="1050" u="none" b="0">
+              <a:rPr lang="en" sz="1200" u="none" b="0">
                 <a:solidFill>
                   <a:srgbClr val="0F1A2A"/>
                 </a:solidFill>
@@ -14244,7 +14244,7 @@
         </p:nvSpPr>
         <p:spPr>
           <a:xfrm>
-            <a:off x="5394900" y="1609344"/>
+            <a:off x="5276850" y="1609344"/>
             <a:ext cx="114300" cy="114300"/>
           </a:xfrm>
           <a:prstGeom prst="ellipse">
@@ -14288,7 +14288,7 @@
         </p:nvSpPr>
         <p:spPr>
           <a:xfrm>
-            <a:off x="5394900" y="2329434"/>
+            <a:off x="5276850" y="2329434"/>
             <a:ext cx="114300" cy="114300"/>
           </a:xfrm>
           <a:prstGeom prst="ellipse">
@@ -14332,7 +14332,7 @@
         </p:nvSpPr>
         <p:spPr>
           <a:xfrm>
-            <a:off x="5394900" y="3049524"/>
+            <a:off x="5276850" y="3049524"/>
             <a:ext cx="114300" cy="114300"/>
           </a:xfrm>
           <a:prstGeom prst="ellipse">
@@ -14376,7 +14376,7 @@
         </p:nvSpPr>
         <p:spPr>
           <a:xfrm>
-            <a:off x="5394900" y="3769614"/>
+            <a:off x="5276850" y="3769614"/>
             <a:ext cx="114300" cy="114300"/>
           </a:xfrm>
           <a:prstGeom prst="ellipse">

</xml_diff>

<commit_message>
Deck: one home for the numbers, T-Mobile slide, animations
- Removes "Which was faster?" (never measured; the live race makes the point)
- Slide 6 is a Formly x T-Mobile slide in T-Mobile's style holding every number
  once: 33 fields (our demo form schema), 1 in 2, up to 50%, $1,835
- Stats and the money column come off slides 3 and 4; the 18% stat is dropped
- Adds a "Questions?" slide and fade transitions plus a few builds
- Hidden answer slides are now 8-11

Co-Authored-By: Claude Opus 5.5 <noreply@anthropic.com>
</commit_message>
<xml_diff>
--- a/deck/Formly-deck.pptx
+++ b/deck/Formly-deck.pptx
@@ -13,7 +13,6 @@
     <p:sldId id="258" r:id="rId8"/>
     <p:sldId id="272" r:id="rId29"/>
     <p:sldId id="259" r:id="rId9"/>
-    <p:sldId id="262" r:id="rId12"/>
     <p:sldId id="268" r:id="rId18"/>
     <p:sldId id="269" r:id="rId19"/>
     <p:sldId id="261" r:id="rId11"/>
@@ -804,7 +803,7 @@
 </p:notes>
 </file>
 
-<file path=ppt/notesSlides/notesSlide12.xml><?xml version="1.0" encoding="utf-8"?>
+<file path=ppt/notesSlides/notesSlide11.xml><?xml version="1.0" encoding="utf-8"?>
 <p:notes xmlns:a="http://schemas.openxmlformats.org/drawingml/2006/main" xmlns:p="http://schemas.openxmlformats.org/presentationml/2006/main" xmlns:r="http://schemas.openxmlformats.org/officeDocument/2006/relationships">
   <p:cSld>
     <p:spTree>
@@ -849,7 +848,7 @@
           <a:lstStyle/>
           <a:p>
             <a:r>
-              <a:t>0:50-1:15 · Still racing. By hand isn't a line: typos, wrong PINs, made-up answers, rejected port-ins, start again or quit. Each account that finishes is about $1,835 a year to T-Mobile ($152.91 a month, Q2 2026). Shopify says prefilled checkout finishes up to 50% more orders; that's their own study, so treat it as a ceiling. Stripe made paying one tap. We make signing up one tap.</a:t>
+              <a:t>0:50-1:15 · Still racing. By hand isn't a line: typos, wrong PINs, made-up answers, rejected port-ins, start again or quit. Click: Formly is one straight line, one tap to signed up. Stripe made paying one tap. We make signing up one tap.</a:t>
             </a:r>
           </a:p>
         </p:txBody>
@@ -938,7 +937,7 @@
           <a:lstStyle/>
           <a:p>
             <a:r>
-              <a:t>1:55-2:10 · Bring Formly to T-Mobile. Say it out loud: less friction, more switchers. The ask: a one-month pilot on T-Mobile's switch flow, measured on completion rate and port-in errors.</a:t>
+              <a:t>1:45-2:10 · Bring Formly to T-Mobile. Walk the cards left to right: 33 fields become one tap; half of Americans are put off switching; prefilled checkouts finish up to 50% more (Shopify's own study, so a ceiling); each new account is $1,835 a year. Then the ask: a one-month pilot, measured on completion rate and port-in errors. Less friction, more switchers.</a:t>
             </a:r>
           </a:p>
         </p:txBody>
@@ -1027,7 +1026,7 @@
           <a:lstStyle/>
           <a:p>
             <a:r>
-              <a:t>2:10-4:30 · Questions. Slides 9-12 are hidden; type the number and press Enter to jump. Isn't this just autofill? 9 · How is it built? 10 · What works today? 11 · Is reading my inbox safe? 12. 4:30-5:00 · Leave them with the QR.</a:t>
+              <a:t>2:10-4:30 · Questions. Slides 8-11 are hidden; type the number and press Enter to jump. Isn't this just autofill? 8 · How is it built? 9 · What works today? 10 · Is reading my inbox safe? 11. 4:30-5:00 · Leave them with the QR.</a:t>
             </a:r>
           </a:p>
         </p:txBody>
@@ -1383,7 +1382,7 @@
           <a:lstStyle/>
           <a:p>
             <a:r>
-              <a:t>0:20-0:50 · Talk while they race. Everyone has typed their address a hundred times. Half of Americans say the hassle of switching puts them off changing carriers (YouGov). 18% of shoppers who quit a checkout blame a long or complicated one (Baymard).</a:t>
+              <a:t>0:20-0:50 · Talk while they race. Everyone has typed their address a hundred times: the bank, the landlord, the DMV. T-Mobile's sign-up alone is 33 fields.</a:t>
             </a:r>
           </a:p>
         </p:txBody>
@@ -1472,7 +1471,7 @@
           <a:lstStyle/>
           <a:p>
             <a:r>
-              <a:t>1:15-1:45 · Race over. Have the judge tap a filled field on the phone: it shows the email or file the answer came from. Account number from the carrier bill in Gmail, phone model from the order receipt, address from the lease on Drive.</a:t>
+              <a:t>1:15-1:45 · Race over: who won? Then have the judge tap a filled field: it shows the email or file the answer came from. Account number from the carrier bill in Gmail, phone model from the order receipt, address from the lease on Drive.</a:t>
             </a:r>
           </a:p>
         </p:txBody>
@@ -1651,95 +1650,6 @@
           <a:p>
             <a:r>
               <a:t>Answer to: isn't this just autofill? Autofill fills your name, password managers fill logins, Stripe Link fills payment. Nothing fills the account number, IMEI or the number you're transferring.</a:t>
-            </a:r>
-          </a:p>
-        </p:txBody>
-      </p:sp>
-    </p:spTree>
-  </p:cSld>
-  <p:clrMapOvr>
-    <a:masterClrMapping/>
-  </p:clrMapOvr>
-</p:notes>
-</file>
-
-<file path=ppt/notesSlides/notesSlide7.xml><?xml version="1.0" encoding="utf-8"?>
-<p:notes xmlns:a="http://schemas.openxmlformats.org/drawingml/2006/main" xmlns:r="http://schemas.openxmlformats.org/officeDocument/2006/relationships" xmlns:mc="http://schemas.openxmlformats.org/markup-compatibility/2006" xmlns:mv="urn:schemas-microsoft-com:mac:vml" xmlns:p="http://schemas.openxmlformats.org/presentationml/2006/main" xmlns:c="http://schemas.openxmlformats.org/drawingml/2006/chart" xmlns:dgm="http://schemas.openxmlformats.org/drawingml/2006/diagram" xmlns:o="urn:schemas-microsoft-com:office:office" xmlns:v="urn:schemas-microsoft-com:vml" xmlns:pvml="urn:schemas-microsoft-com:office:powerpoint" xmlns:com="http://schemas.openxmlformats.org/drawingml/2006/compatibility" xmlns:p14="http://schemas.microsoft.com/office/powerpoint/2010/main" xmlns:p15="http://schemas.microsoft.com/office/powerpoint/2012/main" xmlns:ahyp="http://schemas.microsoft.com/office/drawing/2018/hyperlinkcolor" showMasterPhAnim="0" showMasterSp="0">
-  <p:cSld>
-    <p:spTree>
-      <p:nvGrpSpPr>
-        <p:cNvPr id="183" name="Shape 183"/>
-        <p:cNvGrpSpPr/>
-        <p:nvPr/>
-      </p:nvGrpSpPr>
-      <p:grpSpPr>
-        <a:xfrm>
-          <a:off x="0" y="0"/>
-          <a:ext cx="0" cy="0"/>
-          <a:chOff x="0" y="0"/>
-          <a:chExt cx="0" cy="0"/>
-        </a:xfrm>
-      </p:grpSpPr>
-      <p:sp>
-        <p:nvSpPr>
-          <p:cNvPr id="184" name="Google Shape;184;frdemo:notes"/>
-          <p:cNvSpPr/>
-          <p:nvPr>
-            <p:ph idx="2" type="sldImg"/>
-          </p:nvPr>
-        </p:nvSpPr>
-        <p:spPr>
-          <a:xfrm>
-            <a:off x="381300" y="685800"/>
-            <a:ext cx="6096000" cy="3429000"/>
-          </a:xfrm>
-          <a:custGeom>
-            <a:rect b="b" l="l" r="r" t="t"/>
-            <a:pathLst>
-              <a:path extrusionOk="0" h="120000" w="120000">
-                <a:moveTo>
-                  <a:pt x="0" y="0"/>
-                </a:moveTo>
-                <a:lnTo>
-                  <a:pt x="120000" y="0"/>
-                </a:lnTo>
-                <a:lnTo>
-                  <a:pt x="120000" y="120000"/>
-                </a:lnTo>
-                <a:lnTo>
-                  <a:pt x="0" y="120000"/>
-                </a:lnTo>
-                <a:close/>
-              </a:path>
-            </a:pathLst>
-          </a:custGeom>
-        </p:spPr>
-      </p:sp>
-      <p:sp>
-        <p:nvSpPr>
-          <p:cNvPr id="185" name="Google Shape;185;frdemo:notes"/>
-          <p:cNvSpPr txBox="1"/>
-          <p:nvPr>
-            <p:ph idx="1" type="body"/>
-          </p:nvPr>
-        </p:nvSpPr>
-        <p:spPr>
-          <a:xfrm>
-            <a:off x="685800" y="4343400"/>
-            <a:ext cx="5486400" cy="4114800"/>
-          </a:xfrm>
-          <a:prstGeom prst="rect">
-            <a:avLst/>
-          </a:prstGeom>
-        </p:spPr>
-        <p:txBody>
-          <a:bodyPr anchorCtr="0" anchor="t" bIns="91425" lIns="91425" spcFirstLastPara="1" rIns="91425" wrap="square" tIns="91425">
-            <a:noAutofit/>
-          </a:bodyPr>
-          <a:lstStyle/>
-          <a:p>
-            <a:r>
-              <a:t>1:45-1:55 · Which was faster? Their time against the teammate's. If the race went wrong, point at our measured times on screen.</a:t>
             </a:r>
           </a:p>
         </p:txBody>
@@ -6808,6 +6718,9 @@
   <p:clrMapOvr>
     <a:masterClrMapping/>
   </p:clrMapOvr>
+  <p:transition spd="fast">
+    <p:fade/>
+  </p:transition>
 </p:sld>
 </file>
 
@@ -6817,7 +6730,7 @@
     <p:bg>
       <p:bgPr>
         <a:solidFill>
-          <a:srgbClr val="0F1A2A"/>
+          <a:srgbClr val="FFFFFF"/>
         </a:solidFill>
       </p:bgPr>
     </p:bg>
@@ -6837,294 +6750,856 @@
       </p:grpSpPr>
       <p:sp>
         <p:nvSpPr>
-          <p:cNvPr id="244" name="Google Shape;244;p25"/>
-          <p:cNvSpPr txBox="1"/>
-          <p:nvPr/>
-        </p:nvSpPr>
-        <p:spPr>
-          <a:xfrm>
-            <a:off x="320040" y="342900"/>
-            <a:ext cx="8503800" cy="1028700"/>
+          <p:cNvPr id="244" name="Rectangle 243"/>
+          <p:cNvSpPr/>
+          <p:nvPr/>
+        </p:nvSpPr>
+        <p:spPr>
+          <a:xfrm>
+            <a:off x="0" y="0"/>
+            <a:ext cx="9144000" cy="2032000"/>
           </a:xfrm>
           <a:prstGeom prst="rect">
             <a:avLst/>
           </a:prstGeom>
-          <a:noFill/>
+          <a:solidFill>
+            <a:srgbClr val="E20074"/>
+          </a:solidFill>
           <a:ln>
             <a:noFill/>
           </a:ln>
-        </p:spPr>
-        <p:txBody>
-          <a:bodyPr anchorCtr="0" anchor="t" bIns="91425" lIns="91425" spcFirstLastPara="1" rIns="91425" wrap="square" tIns="91425">
-            <a:noAutofit/>
-          </a:bodyPr>
-          <a:lstStyle/>
-          <a:p>
-            <a:pPr indent="0" lvl="0" marL="0" rtl="0" algn="l">
-              <a:lnSpc>
-                <a:spcPct val="95000"/>
-              </a:lnSpc>
-              <a:spcBef>
-                <a:spcPts val="0"/>
-              </a:spcBef>
-              <a:spcAft>
-                <a:spcPts val="0"/>
-              </a:spcAft>
-              <a:buNone/>
-            </a:pPr>
+          <a:effectLst/>
+        </p:spPr>
+        <p:style>
+          <a:lnRef idx="1">
+            <a:schemeClr val="accent1"/>
+          </a:lnRef>
+          <a:fillRef idx="3">
+            <a:schemeClr val="accent1"/>
+          </a:fillRef>
+          <a:effectRef idx="2">
+            <a:schemeClr val="accent1"/>
+          </a:effectRef>
+          <a:fontRef idx="minor">
+            <a:schemeClr val="lt1"/>
+          </a:fontRef>
+        </p:style>
+        <p:txBody>
+          <a:bodyPr rtlCol="0" anchor="ctr"/>
+          <a:lstStyle/>
+          <a:p>
+            <a:pPr algn="ctr"/>
+          </a:p>
+        </p:txBody>
+      </p:sp>
+      <p:sp>
+        <p:nvSpPr>
+          <p:cNvPr id="245" name="Rounded Rectangle 244"/>
+          <p:cNvSpPr/>
+          <p:nvPr/>
+        </p:nvSpPr>
+        <p:spPr>
+          <a:xfrm>
+            <a:off x="320040" y="279400"/>
+            <a:ext cx="2489200" cy="431800"/>
+          </a:xfrm>
+          <a:prstGeom prst="roundRect">
+            <a:avLst>
+              <a:gd name="adj" fmla="val 50000"/>
+            </a:avLst>
+          </a:prstGeom>
+          <a:solidFill>
+            <a:srgbClr val="FFFFFF"/>
+          </a:solidFill>
+          <a:ln>
+            <a:noFill/>
+          </a:ln>
+          <a:effectLst/>
+        </p:spPr>
+        <p:style>
+          <a:lnRef idx="1">
+            <a:schemeClr val="accent1"/>
+          </a:lnRef>
+          <a:fillRef idx="3">
+            <a:schemeClr val="accent1"/>
+          </a:fillRef>
+          <a:effectRef idx="2">
+            <a:schemeClr val="accent1"/>
+          </a:effectRef>
+          <a:fontRef idx="minor">
+            <a:schemeClr val="lt1"/>
+          </a:fontRef>
+        </p:style>
+        <p:txBody>
+          <a:bodyPr rtlCol="0" anchor="ctr"/>
+          <a:lstStyle/>
+          <a:p>
+            <a:pPr algn="ctr"/>
+          </a:p>
+        </p:txBody>
+      </p:sp>
+      <p:pic>
+        <p:nvPicPr>
+          <p:cNvPr id="246" name="Picture 245" descr="lockup-light.png"/>
+          <p:cNvPicPr>
+            <a:picLocks noChangeAspect="1"/>
+          </p:cNvPicPr>
+          <p:nvPr/>
+        </p:nvPicPr>
+        <p:blipFill>
+          <a:blip r:embed="rId3"/>
+          <a:stretch>
+            <a:fillRect/>
+          </a:stretch>
+        </p:blipFill>
+        <p:spPr>
+          <a:xfrm>
+            <a:off x="482600" y="381000"/>
+            <a:ext cx="909680" cy="228600"/>
+          </a:xfrm>
+          <a:prstGeom prst="rect">
+            <a:avLst/>
+          </a:prstGeom>
+        </p:spPr>
+      </p:pic>
+      <p:sp>
+        <p:nvSpPr>
+          <p:cNvPr id="247" name="TextBox 246"/>
+          <p:cNvSpPr txBox="1"/>
+          <p:nvPr/>
+        </p:nvSpPr>
+        <p:spPr>
+          <a:xfrm>
+            <a:off x="1384300" y="279400"/>
+            <a:ext cx="228600" cy="431800"/>
+          </a:xfrm>
+          <a:prstGeom prst="rect">
+            <a:avLst/>
+          </a:prstGeom>
+          <a:noFill/>
+        </p:spPr>
+        <p:txBody>
+          <a:bodyPr wrap="square" anchor="ctr" lIns="45720" rIns="45720">
+            <a:spAutoFit/>
+          </a:bodyPr>
+          <a:lstStyle/>
+          <a:p>
+            <a:pPr algn="ctr"/>
             <a:r>
-              <a:rPr lang="en" sz="2700" b="0">
+              <a:rPr sz="1400" b="0">
+                <a:solidFill>
+                  <a:srgbClr val="141414"/>
+                </a:solidFill>
+                <a:latin typeface="Inter"/>
+              </a:rPr>
+              <a:t>×</a:t>
+            </a:r>
+          </a:p>
+        </p:txBody>
+      </p:sp>
+      <p:pic>
+        <p:nvPicPr>
+          <p:cNvPr id="248" name="Picture 247" descr="tmobile-logo.png"/>
+          <p:cNvPicPr>
+            <a:picLocks noChangeAspect="1"/>
+          </p:cNvPicPr>
+          <p:nvPr/>
+        </p:nvPicPr>
+        <p:blipFill>
+          <a:blip r:embed="rId4"/>
+          <a:stretch>
+            <a:fillRect/>
+          </a:stretch>
+        </p:blipFill>
+        <p:spPr>
+          <a:xfrm>
+            <a:off x="1638300" y="393700"/>
+            <a:ext cx="1004994" cy="203200"/>
+          </a:xfrm>
+          <a:prstGeom prst="rect">
+            <a:avLst/>
+          </a:prstGeom>
+        </p:spPr>
+      </p:pic>
+      <p:sp>
+        <p:nvSpPr>
+          <p:cNvPr id="249" name="TextBox 248"/>
+          <p:cNvSpPr txBox="1"/>
+          <p:nvPr/>
+        </p:nvSpPr>
+        <p:spPr>
+          <a:xfrm>
+            <a:off x="320040" y="787400"/>
+            <a:ext cx="8509000" cy="635000"/>
+          </a:xfrm>
+          <a:prstGeom prst="rect">
+            <a:avLst/>
+          </a:prstGeom>
+          <a:noFill/>
+        </p:spPr>
+        <p:txBody>
+          <a:bodyPr wrap="square" anchor="t" lIns="45720" rIns="45720">
+            <a:spAutoFit/>
+          </a:bodyPr>
+          <a:lstStyle/>
+          <a:p>
+            <a:pPr algn="l"/>
+            <a:r>
+              <a:rPr sz="4000" b="1">
                 <a:solidFill>
                   <a:srgbClr val="FFFFFF"/>
                 </a:solidFill>
-                <a:latin typeface="Sora SemiBold"/>
-                <a:ea typeface="Sora SemiBold"/>
-                <a:cs typeface="Sora SemiBold"/>
-                <a:sym typeface="Sora SemiBold"/>
+                <a:latin typeface="Inter Display"/>
               </a:rPr>
               <a:t>Bring Formly to T-Mobile.</a:t>
             </a:r>
-            <a:endParaRPr sz="2700" b="0">
-              <a:solidFill>
-                <a:srgbClr val="FFFFFF"/>
-              </a:solidFill>
-              <a:latin typeface="Sora SemiBold"/>
-              <a:ea typeface="Sora SemiBold"/>
-              <a:cs typeface="Sora SemiBold"/>
-              <a:sym typeface="Sora SemiBold"/>
-            </a:endParaRPr>
-          </a:p>
-        </p:txBody>
-      </p:sp>
-      <p:sp>
-        <p:nvSpPr>
-          <p:cNvPr id="245" name="Google Shape;245;p25"/>
+          </a:p>
+        </p:txBody>
+      </p:sp>
+      <p:sp>
+        <p:nvSpPr>
+          <p:cNvPr id="250" name="TextBox 249"/>
           <p:cNvSpPr txBox="1"/>
           <p:nvPr/>
         </p:nvSpPr>
         <p:spPr>
           <a:xfrm>
-            <a:off x="320040" y="1337310"/>
-            <a:ext cx="8412600" cy="960000"/>
+            <a:off x="320040" y="1422400"/>
+            <a:ext cx="7874000" cy="508000"/>
           </a:xfrm>
           <a:prstGeom prst="rect">
             <a:avLst/>
           </a:prstGeom>
           <a:noFill/>
-          <a:ln>
-            <a:noFill/>
-          </a:ln>
-        </p:spPr>
-        <p:txBody>
-          <a:bodyPr anchorCtr="0" anchor="t" bIns="91425" lIns="91425" spcFirstLastPara="1" rIns="91425" wrap="square" tIns="91425">
-            <a:noAutofit/>
-          </a:bodyPr>
-          <a:lstStyle/>
-          <a:p>
-            <a:pPr indent="0" lvl="0" marL="0" rtl="0" algn="l">
-              <a:spcBef>
-                <a:spcPts val="0"/>
-              </a:spcBef>
-              <a:spcAft>
-                <a:spcPts val="0"/>
-              </a:spcAft>
-              <a:buNone/>
-            </a:pPr>
+        </p:spPr>
+        <p:txBody>
+          <a:bodyPr wrap="square" anchor="t" lIns="45720" rIns="45720">
+            <a:spAutoFit/>
+          </a:bodyPr>
+          <a:lstStyle/>
+          <a:p>
+            <a:pPr algn="l"/>
             <a:r>
-              <a:rPr lang="en" sz="6000" b="0">
-                <a:solidFill>
-                  <a:srgbClr val="22C985"/>
-                </a:solidFill>
-                <a:latin typeface="Sora SemiBold"/>
-                <a:ea typeface="Sora SemiBold"/>
-                <a:cs typeface="Sora SemiBold"/>
-                <a:sym typeface="Sora SemiBold"/>
-              </a:rPr>
-              <a:t>[X]× faster</a:t>
-            </a:r>
-            <a:endParaRPr sz="6000" b="0">
-              <a:solidFill>
-                <a:srgbClr val="22C985"/>
-              </a:solidFill>
-              <a:latin typeface="Sora SemiBold"/>
-              <a:ea typeface="Sora SemiBold"/>
-              <a:cs typeface="Sora SemiBold"/>
-              <a:sym typeface="Sora SemiBold"/>
-            </a:endParaRPr>
-          </a:p>
-        </p:txBody>
-      </p:sp>
-      <p:sp>
-        <p:nvSpPr>
-          <p:cNvPr id="246" name="Google Shape;246;p25"/>
-          <p:cNvSpPr txBox="1"/>
-          <p:nvPr/>
-        </p:nvSpPr>
-        <p:spPr>
-          <a:xfrm>
-            <a:off x="320040" y="2366010"/>
-            <a:ext cx="8412600" cy="548700"/>
-          </a:xfrm>
-          <a:prstGeom prst="rect">
-            <a:avLst/>
-          </a:prstGeom>
-          <a:noFill/>
-          <a:ln>
-            <a:noFill/>
-          </a:ln>
-        </p:spPr>
-        <p:txBody>
-          <a:bodyPr anchorCtr="0" anchor="t" bIns="91425" lIns="91425" spcFirstLastPara="1" rIns="91425" wrap="square" tIns="91425">
-            <a:noAutofit/>
-          </a:bodyPr>
-          <a:lstStyle/>
-          <a:p>
-            <a:pPr indent="0" lvl="0" marL="0" rtl="0" algn="l">
-              <a:spcBef>
-                <a:spcPts val="0"/>
-              </a:spcBef>
-              <a:spcAft>
-                <a:spcPts val="0"/>
-              </a:spcAft>
-              <a:buNone/>
-            </a:pPr>
-            <a:r>
-              <a:rPr lang="en" sz="1200" b="0">
+              <a:rPr sz="1300" b="0">
                 <a:solidFill>
                   <a:srgbClr val="FFFFFF"/>
                 </a:solidFill>
-                <a:latin typeface="DM Sans"/>
-                <a:ea typeface="DM Sans"/>
-                <a:cs typeface="DM Sans"/>
-                <a:sym typeface="DM Sans"/>
+                <a:latin typeface="Inter"/>
               </a:rPr>
-              <a:t>to a finished switch form, measured on our replica · fewer people quit halfway</a:t>
+              <a:t>The ask: a one-month pilot of Fill with Formly on T-Mobile's switch flow, measured on completion rate and port-in errors.</a:t>
             </a:r>
-            <a:endParaRPr sz="1200" b="0">
-              <a:solidFill>
-                <a:srgbClr val="FFFFFF"/>
-              </a:solidFill>
-              <a:latin typeface="DM Sans"/>
-              <a:ea typeface="DM Sans"/>
-              <a:cs typeface="DM Sans"/>
-              <a:sym typeface="DM Sans"/>
-            </a:endParaRPr>
-          </a:p>
-        </p:txBody>
-      </p:sp>
-      <p:sp>
-        <p:nvSpPr>
-          <p:cNvPr id="247" name="Google Shape;247;p25"/>
+          </a:p>
+        </p:txBody>
+      </p:sp>
+      <p:sp>
+        <p:nvSpPr>
+          <p:cNvPr id="251" name="Rounded Rectangle 250"/>
+          <p:cNvSpPr/>
+          <p:nvPr/>
+        </p:nvSpPr>
+        <p:spPr>
+          <a:xfrm>
+            <a:off x="320040" y="2362200"/>
+            <a:ext cx="2011680" cy="2413000"/>
+          </a:xfrm>
+          <a:prstGeom prst="roundRect">
+            <a:avLst>
+              <a:gd name="adj" fmla="val 7000"/>
+            </a:avLst>
+          </a:prstGeom>
+          <a:solidFill>
+            <a:srgbClr val="FFFFFF"/>
+          </a:solidFill>
+          <a:ln w="12700">
+            <a:solidFill>
+              <a:srgbClr val="E6E6E6"/>
+            </a:solidFill>
+          </a:ln>
+          <a:effectLst/>
+        </p:spPr>
+        <p:style>
+          <a:lnRef idx="1">
+            <a:schemeClr val="accent1"/>
+          </a:lnRef>
+          <a:fillRef idx="3">
+            <a:schemeClr val="accent1"/>
+          </a:fillRef>
+          <a:effectRef idx="2">
+            <a:schemeClr val="accent1"/>
+          </a:effectRef>
+          <a:fontRef idx="minor">
+            <a:schemeClr val="lt1"/>
+          </a:fontRef>
+        </p:style>
+        <p:txBody>
+          <a:bodyPr rtlCol="0" anchor="ctr"/>
+          <a:lstStyle/>
+          <a:p>
+            <a:pPr algn="ctr"/>
+          </a:p>
+        </p:txBody>
+      </p:sp>
+      <p:sp>
+        <p:nvSpPr>
+          <p:cNvPr id="252" name="TextBox 251"/>
           <p:cNvSpPr txBox="1"/>
           <p:nvPr/>
         </p:nvSpPr>
         <p:spPr>
           <a:xfrm>
-            <a:off x="320040" y="3154680"/>
-            <a:ext cx="8069700" cy="617100"/>
+            <a:off x="421640" y="2565400"/>
+            <a:ext cx="1803400" cy="431800"/>
           </a:xfrm>
           <a:prstGeom prst="rect">
             <a:avLst/>
           </a:prstGeom>
           <a:noFill/>
-          <a:ln>
-            <a:noFill/>
+        </p:spPr>
+        <p:txBody>
+          <a:bodyPr wrap="square" anchor="t" lIns="45720" rIns="45720">
+            <a:spAutoFit/>
+          </a:bodyPr>
+          <a:lstStyle/>
+          <a:p>
+            <a:pPr algn="l"/>
+            <a:r>
+              <a:rPr sz="2200" b="1">
+                <a:solidFill>
+                  <a:srgbClr val="141414"/>
+                </a:solidFill>
+                <a:latin typeface="Inter Display"/>
+              </a:rPr>
+              <a:t>33</a:t>
+            </a:r>
+          </a:p>
+        </p:txBody>
+      </p:sp>
+      <p:sp>
+        <p:nvSpPr>
+          <p:cNvPr id="253" name="TextBox 252"/>
+          <p:cNvSpPr txBox="1"/>
+          <p:nvPr/>
+        </p:nvSpPr>
+        <p:spPr>
+          <a:xfrm>
+            <a:off x="421640" y="3098800"/>
+            <a:ext cx="1803400" cy="1143000"/>
+          </a:xfrm>
+          <a:prstGeom prst="rect">
+            <a:avLst/>
+          </a:prstGeom>
+          <a:noFill/>
+        </p:spPr>
+        <p:txBody>
+          <a:bodyPr wrap="square" anchor="t" lIns="45720" rIns="45720">
+            <a:spAutoFit/>
+          </a:bodyPr>
+          <a:lstStyle/>
+          <a:p>
+            <a:pPr algn="l"/>
+            <a:r>
+              <a:rPr sz="1050" b="0">
+                <a:solidFill>
+                  <a:srgbClr val="141414"/>
+                </a:solidFill>
+                <a:latin typeface="Inter"/>
+              </a:rPr>
+              <a:t>fields on T-Mobile's sign-up (our replica). Formly fills them in one tap.</a:t>
+            </a:r>
+          </a:p>
+        </p:txBody>
+      </p:sp>
+      <p:sp>
+        <p:nvSpPr>
+          <p:cNvPr id="254" name="TextBox 253"/>
+          <p:cNvSpPr txBox="1"/>
+          <p:nvPr/>
+        </p:nvSpPr>
+        <p:spPr>
+          <a:xfrm>
+            <a:off x="421640" y="4419600"/>
+            <a:ext cx="1803400" cy="254000"/>
+          </a:xfrm>
+          <a:prstGeom prst="rect">
+            <a:avLst/>
+          </a:prstGeom>
+          <a:noFill/>
+        </p:spPr>
+        <p:txBody>
+          <a:bodyPr wrap="square" anchor="t" lIns="45720" rIns="45720">
+            <a:spAutoFit/>
+          </a:bodyPr>
+          <a:lstStyle/>
+          <a:p>
+            <a:pPr algn="l"/>
+            <a:r>
+              <a:rPr sz="750" b="0">
+                <a:solidFill>
+                  <a:srgbClr val="6A6A6A"/>
+                </a:solidFill>
+                <a:latin typeface="Inter"/>
+              </a:rPr>
+              <a:t>Our T-Mobile demo form</a:t>
+            </a:r>
+          </a:p>
+        </p:txBody>
+      </p:sp>
+      <p:sp>
+        <p:nvSpPr>
+          <p:cNvPr id="255" name="Rounded Rectangle 254"/>
+          <p:cNvSpPr/>
+          <p:nvPr/>
+        </p:nvSpPr>
+        <p:spPr>
+          <a:xfrm>
+            <a:off x="2484120" y="2362200"/>
+            <a:ext cx="2011680" cy="2413000"/>
+          </a:xfrm>
+          <a:prstGeom prst="roundRect">
+            <a:avLst>
+              <a:gd name="adj" fmla="val 7000"/>
+            </a:avLst>
+          </a:prstGeom>
+          <a:solidFill>
+            <a:srgbClr val="FFFFFF"/>
+          </a:solidFill>
+          <a:ln w="12700">
+            <a:solidFill>
+              <a:srgbClr val="E6E6E6"/>
+            </a:solidFill>
           </a:ln>
-        </p:spPr>
-        <p:txBody>
-          <a:bodyPr anchorCtr="0" anchor="t" bIns="91425" lIns="91425" spcFirstLastPara="1" rIns="91425" wrap="square" tIns="91425">
-            <a:noAutofit/>
-          </a:bodyPr>
-          <a:lstStyle/>
-          <a:p>
-            <a:pPr indent="0" lvl="0" marL="0" rtl="0" algn="l">
-              <a:spcBef>
-                <a:spcPts val="0"/>
-              </a:spcBef>
-              <a:spcAft>
-                <a:spcPts val="0"/>
-              </a:spcAft>
-              <a:buNone/>
-            </a:pPr>
+          <a:effectLst/>
+        </p:spPr>
+        <p:style>
+          <a:lnRef idx="1">
+            <a:schemeClr val="accent1"/>
+          </a:lnRef>
+          <a:fillRef idx="3">
+            <a:schemeClr val="accent1"/>
+          </a:fillRef>
+          <a:effectRef idx="2">
+            <a:schemeClr val="accent1"/>
+          </a:effectRef>
+          <a:fontRef idx="minor">
+            <a:schemeClr val="lt1"/>
+          </a:fontRef>
+        </p:style>
+        <p:txBody>
+          <a:bodyPr rtlCol="0" anchor="ctr"/>
+          <a:lstStyle/>
+          <a:p>
+            <a:pPr algn="ctr"/>
+          </a:p>
+        </p:txBody>
+      </p:sp>
+      <p:sp>
+        <p:nvSpPr>
+          <p:cNvPr id="256" name="TextBox 255"/>
+          <p:cNvSpPr txBox="1"/>
+          <p:nvPr/>
+        </p:nvSpPr>
+        <p:spPr>
+          <a:xfrm>
+            <a:off x="2585720" y="2565400"/>
+            <a:ext cx="1803400" cy="431800"/>
+          </a:xfrm>
+          <a:prstGeom prst="rect">
+            <a:avLst/>
+          </a:prstGeom>
+          <a:noFill/>
+        </p:spPr>
+        <p:txBody>
+          <a:bodyPr wrap="square" anchor="t" lIns="45720" rIns="45720">
+            <a:spAutoFit/>
+          </a:bodyPr>
+          <a:lstStyle/>
+          <a:p>
+            <a:pPr algn="l"/>
             <a:r>
-              <a:rPr b="0" lang="en" sz="1350">
+              <a:rPr sz="2200" b="1">
                 <a:solidFill>
-                  <a:srgbClr val="FFFFFF"/>
+                  <a:srgbClr val="141414"/>
                 </a:solidFill>
-                <a:latin typeface="DM Sans Medium"/>
-                <a:ea typeface="DM Sans Medium"/>
-                <a:cs typeface="DM Sans Medium"/>
-                <a:sym typeface="DM Sans Medium"/>
+                <a:latin typeface="Inter Display"/>
               </a:rPr>
-              <a:t>Our ask: a one-month pilot of Fill with Formly on T-Mobile's switch flow, measured on completion rate and port-in errors.</a:t>
+              <a:t>1 in 2</a:t>
             </a:r>
-            <a:endParaRPr b="0" sz="1350">
-              <a:solidFill>
-                <a:srgbClr val="FFFFFF"/>
-              </a:solidFill>
-              <a:latin typeface="DM Sans Medium"/>
-              <a:ea typeface="DM Sans Medium"/>
-              <a:cs typeface="DM Sans Medium"/>
-              <a:sym typeface="DM Sans Medium"/>
-            </a:endParaRPr>
-          </a:p>
-        </p:txBody>
-      </p:sp>
-      <p:sp>
-        <p:nvSpPr>
-          <p:cNvPr id="248" name="Google Shape;248;p25"/>
+          </a:p>
+        </p:txBody>
+      </p:sp>
+      <p:sp>
+        <p:nvSpPr>
+          <p:cNvPr id="257" name="TextBox 256"/>
           <p:cNvSpPr txBox="1"/>
           <p:nvPr/>
         </p:nvSpPr>
         <p:spPr>
           <a:xfrm>
-            <a:off x="320040" y="4629150"/>
-            <a:ext cx="8412600" cy="240000"/>
+            <a:off x="2585720" y="3098800"/>
+            <a:ext cx="1803400" cy="1143000"/>
           </a:xfrm>
           <a:prstGeom prst="rect">
             <a:avLst/>
           </a:prstGeom>
           <a:noFill/>
-          <a:ln>
-            <a:noFill/>
+        </p:spPr>
+        <p:txBody>
+          <a:bodyPr wrap="square" anchor="t" lIns="45720" rIns="45720">
+            <a:spAutoFit/>
+          </a:bodyPr>
+          <a:lstStyle/>
+          <a:p>
+            <a:pPr algn="l"/>
+            <a:r>
+              <a:rPr sz="1050" b="0">
+                <a:solidFill>
+                  <a:srgbClr val="141414"/>
+                </a:solidFill>
+                <a:latin typeface="Inter"/>
+              </a:rPr>
+              <a:t>Americans say the hassle of switching puts them off changing carriers.</a:t>
+            </a:r>
+          </a:p>
+        </p:txBody>
+      </p:sp>
+      <p:sp>
+        <p:nvSpPr>
+          <p:cNvPr id="258" name="TextBox 257"/>
+          <p:cNvSpPr txBox="1"/>
+          <p:nvPr/>
+        </p:nvSpPr>
+        <p:spPr>
+          <a:xfrm>
+            <a:off x="2585720" y="4419600"/>
+            <a:ext cx="1803400" cy="254000"/>
+          </a:xfrm>
+          <a:prstGeom prst="rect">
+            <a:avLst/>
+          </a:prstGeom>
+          <a:noFill/>
+        </p:spPr>
+        <p:txBody>
+          <a:bodyPr wrap="square" anchor="t" lIns="45720" rIns="45720">
+            <a:spAutoFit/>
+          </a:bodyPr>
+          <a:lstStyle/>
+          <a:p>
+            <a:pPr algn="l"/>
+            <a:r>
+              <a:rPr sz="750" b="0">
+                <a:solidFill>
+                  <a:srgbClr val="6A6A6A"/>
+                </a:solidFill>
+                <a:latin typeface="Inter"/>
+              </a:rPr>
+              <a:t>YouGov, 2023</a:t>
+            </a:r>
+          </a:p>
+        </p:txBody>
+      </p:sp>
+      <p:sp>
+        <p:nvSpPr>
+          <p:cNvPr id="259" name="Rounded Rectangle 258"/>
+          <p:cNvSpPr/>
+          <p:nvPr/>
+        </p:nvSpPr>
+        <p:spPr>
+          <a:xfrm>
+            <a:off x="4648200" y="2362200"/>
+            <a:ext cx="2011680" cy="2413000"/>
+          </a:xfrm>
+          <a:prstGeom prst="roundRect">
+            <a:avLst>
+              <a:gd name="adj" fmla="val 7000"/>
+            </a:avLst>
+          </a:prstGeom>
+          <a:solidFill>
+            <a:srgbClr val="FFFFFF"/>
+          </a:solidFill>
+          <a:ln w="12700">
+            <a:solidFill>
+              <a:srgbClr val="E6E6E6"/>
+            </a:solidFill>
           </a:ln>
-        </p:spPr>
-        <p:txBody>
-          <a:bodyPr anchorCtr="0" anchor="t" bIns="91425" lIns="91425" spcFirstLastPara="1" rIns="91425" wrap="square" tIns="91425">
-            <a:noAutofit/>
-          </a:bodyPr>
-          <a:lstStyle/>
-          <a:p>
-            <a:pPr indent="0" lvl="0" marL="0" rtl="0" algn="l">
-              <a:spcBef>
-                <a:spcPts val="0"/>
-              </a:spcBef>
-              <a:spcAft>
-                <a:spcPts val="0"/>
-              </a:spcAft>
-              <a:buNone/>
-            </a:pPr>
+          <a:effectLst/>
+        </p:spPr>
+        <p:style>
+          <a:lnRef idx="1">
+            <a:schemeClr val="accent1"/>
+          </a:lnRef>
+          <a:fillRef idx="3">
+            <a:schemeClr val="accent1"/>
+          </a:fillRef>
+          <a:effectRef idx="2">
+            <a:schemeClr val="accent1"/>
+          </a:effectRef>
+          <a:fontRef idx="minor">
+            <a:schemeClr val="lt1"/>
+          </a:fontRef>
+        </p:style>
+        <p:txBody>
+          <a:bodyPr rtlCol="0" anchor="ctr"/>
+          <a:lstStyle/>
+          <a:p>
+            <a:pPr algn="ctr"/>
+          </a:p>
+        </p:txBody>
+      </p:sp>
+      <p:sp>
+        <p:nvSpPr>
+          <p:cNvPr id="260" name="TextBox 259"/>
+          <p:cNvSpPr txBox="1"/>
+          <p:nvPr/>
+        </p:nvSpPr>
+        <p:spPr>
+          <a:xfrm>
+            <a:off x="4749800" y="2565400"/>
+            <a:ext cx="1803400" cy="431800"/>
+          </a:xfrm>
+          <a:prstGeom prst="rect">
+            <a:avLst/>
+          </a:prstGeom>
+          <a:noFill/>
+        </p:spPr>
+        <p:txBody>
+          <a:bodyPr wrap="square" anchor="t" lIns="45720" rIns="45720">
+            <a:spAutoFit/>
+          </a:bodyPr>
+          <a:lstStyle/>
+          <a:p>
+            <a:pPr algn="l"/>
             <a:r>
-              <a:rPr lang="en" sz="900" b="0">
+              <a:rPr sz="2200" b="1">
                 <a:solidFill>
-                  <a:srgbClr val="CBD1DA"/>
+                  <a:srgbClr val="141414"/>
                 </a:solidFill>
-                <a:latin typeface="DM Sans"/>
-                <a:ea typeface="DM Sans"/>
-                <a:cs typeface="DM Sans"/>
-                <a:sym typeface="DM Sans"/>
+                <a:latin typeface="Inter Display"/>
               </a:rPr>
-              <a:t>Khangai Sukhbaatar · Salvo Bonsma · Jerry Zheng · Arjun Jindal</a:t>
+              <a:t>up to 50%</a:t>
             </a:r>
-            <a:endParaRPr sz="900" b="0">
-              <a:solidFill>
-                <a:srgbClr val="CBD1DA"/>
-              </a:solidFill>
-              <a:latin typeface="DM Sans"/>
-              <a:ea typeface="DM Sans"/>
-              <a:cs typeface="DM Sans"/>
-              <a:sym typeface="DM Sans"/>
-            </a:endParaRPr>
+          </a:p>
+        </p:txBody>
+      </p:sp>
+      <p:sp>
+        <p:nvSpPr>
+          <p:cNvPr id="261" name="TextBox 260"/>
+          <p:cNvSpPr txBox="1"/>
+          <p:nvPr/>
+        </p:nvSpPr>
+        <p:spPr>
+          <a:xfrm>
+            <a:off x="4749800" y="3098800"/>
+            <a:ext cx="1803400" cy="1143000"/>
+          </a:xfrm>
+          <a:prstGeom prst="rect">
+            <a:avLst/>
+          </a:prstGeom>
+          <a:noFill/>
+        </p:spPr>
+        <p:txBody>
+          <a:bodyPr wrap="square" anchor="t" lIns="45720" rIns="45720">
+            <a:spAutoFit/>
+          </a:bodyPr>
+          <a:lstStyle/>
+          <a:p>
+            <a:pPr algn="l"/>
+            <a:r>
+              <a:rPr sz="1050" b="0">
+                <a:solidFill>
+                  <a:srgbClr val="141414"/>
+                </a:solidFill>
+                <a:latin typeface="Inter"/>
+              </a:rPr>
+              <a:t>more checkouts finished when the form is prefilled.</a:t>
+            </a:r>
+          </a:p>
+        </p:txBody>
+      </p:sp>
+      <p:sp>
+        <p:nvSpPr>
+          <p:cNvPr id="262" name="TextBox 261"/>
+          <p:cNvSpPr txBox="1"/>
+          <p:nvPr/>
+        </p:nvSpPr>
+        <p:spPr>
+          <a:xfrm>
+            <a:off x="4749800" y="4419600"/>
+            <a:ext cx="1803400" cy="254000"/>
+          </a:xfrm>
+          <a:prstGeom prst="rect">
+            <a:avLst/>
+          </a:prstGeom>
+          <a:noFill/>
+        </p:spPr>
+        <p:txBody>
+          <a:bodyPr wrap="square" anchor="t" lIns="45720" rIns="45720">
+            <a:spAutoFit/>
+          </a:bodyPr>
+          <a:lstStyle/>
+          <a:p>
+            <a:pPr algn="l"/>
+            <a:r>
+              <a:rPr sz="750" b="0">
+                <a:solidFill>
+                  <a:srgbClr val="6A6A6A"/>
+                </a:solidFill>
+                <a:latin typeface="Inter"/>
+              </a:rPr>
+              <a:t>Shopify, Shop Pay study</a:t>
+            </a:r>
+          </a:p>
+        </p:txBody>
+      </p:sp>
+      <p:sp>
+        <p:nvSpPr>
+          <p:cNvPr id="263" name="Rounded Rectangle 262"/>
+          <p:cNvSpPr/>
+          <p:nvPr/>
+        </p:nvSpPr>
+        <p:spPr>
+          <a:xfrm>
+            <a:off x="6812280" y="2362200"/>
+            <a:ext cx="2011680" cy="2413000"/>
+          </a:xfrm>
+          <a:prstGeom prst="roundRect">
+            <a:avLst>
+              <a:gd name="adj" fmla="val 7000"/>
+            </a:avLst>
+          </a:prstGeom>
+          <a:solidFill>
+            <a:srgbClr val="FFFFFF"/>
+          </a:solidFill>
+          <a:ln w="12700">
+            <a:solidFill>
+              <a:srgbClr val="E6E6E6"/>
+            </a:solidFill>
+          </a:ln>
+          <a:effectLst/>
+        </p:spPr>
+        <p:style>
+          <a:lnRef idx="1">
+            <a:schemeClr val="accent1"/>
+          </a:lnRef>
+          <a:fillRef idx="3">
+            <a:schemeClr val="accent1"/>
+          </a:fillRef>
+          <a:effectRef idx="2">
+            <a:schemeClr val="accent1"/>
+          </a:effectRef>
+          <a:fontRef idx="minor">
+            <a:schemeClr val="lt1"/>
+          </a:fontRef>
+        </p:style>
+        <p:txBody>
+          <a:bodyPr rtlCol="0" anchor="ctr"/>
+          <a:lstStyle/>
+          <a:p>
+            <a:pPr algn="ctr"/>
+          </a:p>
+        </p:txBody>
+      </p:sp>
+      <p:sp>
+        <p:nvSpPr>
+          <p:cNvPr id="264" name="TextBox 263"/>
+          <p:cNvSpPr txBox="1"/>
+          <p:nvPr/>
+        </p:nvSpPr>
+        <p:spPr>
+          <a:xfrm>
+            <a:off x="6913880" y="2565400"/>
+            <a:ext cx="1803400" cy="431800"/>
+          </a:xfrm>
+          <a:prstGeom prst="rect">
+            <a:avLst/>
+          </a:prstGeom>
+          <a:noFill/>
+        </p:spPr>
+        <p:txBody>
+          <a:bodyPr wrap="square" anchor="t" lIns="45720" rIns="45720">
+            <a:spAutoFit/>
+          </a:bodyPr>
+          <a:lstStyle/>
+          <a:p>
+            <a:pPr algn="l"/>
+            <a:r>
+              <a:rPr sz="2200" b="1">
+                <a:solidFill>
+                  <a:srgbClr val="E20074"/>
+                </a:solidFill>
+                <a:latin typeface="Inter Display"/>
+              </a:rPr>
+              <a:t>$1,835</a:t>
+            </a:r>
+          </a:p>
+        </p:txBody>
+      </p:sp>
+      <p:sp>
+        <p:nvSpPr>
+          <p:cNvPr id="265" name="TextBox 264"/>
+          <p:cNvSpPr txBox="1"/>
+          <p:nvPr/>
+        </p:nvSpPr>
+        <p:spPr>
+          <a:xfrm>
+            <a:off x="6913880" y="3098800"/>
+            <a:ext cx="1803400" cy="1143000"/>
+          </a:xfrm>
+          <a:prstGeom prst="rect">
+            <a:avLst/>
+          </a:prstGeom>
+          <a:noFill/>
+        </p:spPr>
+        <p:txBody>
+          <a:bodyPr wrap="square" anchor="t" lIns="45720" rIns="45720">
+            <a:spAutoFit/>
+          </a:bodyPr>
+          <a:lstStyle/>
+          <a:p>
+            <a:pPr algn="l"/>
+            <a:r>
+              <a:rPr sz="1050" b="0">
+                <a:solidFill>
+                  <a:srgbClr val="141414"/>
+                </a:solidFill>
+                <a:latin typeface="Inter"/>
+              </a:rPr>
+              <a:t>a year from each new T-Mobile postpaid account.</a:t>
+            </a:r>
+          </a:p>
+        </p:txBody>
+      </p:sp>
+      <p:sp>
+        <p:nvSpPr>
+          <p:cNvPr id="266" name="TextBox 265"/>
+          <p:cNvSpPr txBox="1"/>
+          <p:nvPr/>
+        </p:nvSpPr>
+        <p:spPr>
+          <a:xfrm>
+            <a:off x="6913880" y="4419600"/>
+            <a:ext cx="1803400" cy="254000"/>
+          </a:xfrm>
+          <a:prstGeom prst="rect">
+            <a:avLst/>
+          </a:prstGeom>
+          <a:noFill/>
+        </p:spPr>
+        <p:txBody>
+          <a:bodyPr wrap="square" anchor="t" lIns="45720" rIns="45720">
+            <a:spAutoFit/>
+          </a:bodyPr>
+          <a:lstStyle/>
+          <a:p>
+            <a:pPr algn="l"/>
+            <a:r>
+              <a:rPr sz="750" b="0">
+                <a:solidFill>
+                  <a:srgbClr val="6A6A6A"/>
+                </a:solidFill>
+                <a:latin typeface="Inter"/>
+              </a:rPr>
+              <a:t>T-Mobile Q2 2026 results</a:t>
+            </a:r>
           </a:p>
         </p:txBody>
       </p:sp>
@@ -7133,6 +7608,638 @@
   <p:clrMapOvr>
     <a:masterClrMapping/>
   </p:clrMapOvr>
+  <p:transition spd="fast">
+    <p:fade/>
+  </p:transition>
+  <p:timing>
+    <p:tnLst>
+      <p:par>
+        <p:cTn id="1" dur="indefinite" restart="never" nodeType="tmRoot">
+          <p:childTnLst>
+            <p:seq concurrent="1" nextAc="seek">
+              <p:cTn id="2" dur="indefinite" nodeType="mainSeq">
+                <p:childTnLst>
+                  <p:par>
+                    <p:cTn id="3" fill="hold">
+                      <p:stCondLst>
+                        <p:cond delay="indefinite"/>
+                        <p:cond evt="onBegin" delay="0">
+                          <p:tn val="2"/>
+                        </p:cond>
+                      </p:stCondLst>
+                      <p:childTnLst>
+                        <p:par>
+                          <p:cTn id="4" fill="hold">
+                            <p:stCondLst>
+                              <p:cond delay="0"/>
+                            </p:stCondLst>
+                            <p:childTnLst>
+                              <p:par>
+                                <p:cTn id="5" presetID="10" presetClass="entr" presetSubtype="0" fill="hold" grpId="0" nodeType="afterEffect">
+                                  <p:stCondLst>
+                                    <p:cond delay="150"/>
+                                  </p:stCondLst>
+                                  <p:childTnLst>
+                                    <p:set>
+                                      <p:cBhvr>
+                                        <p:cTn id="6" dur="1" fill="hold">
+                                          <p:stCondLst>
+                                            <p:cond delay="0"/>
+                                          </p:stCondLst>
+                                        </p:cTn>
+                                        <p:tgtEl>
+                                          <p:spTgt spid="251"/>
+                                        </p:tgtEl>
+                                        <p:attrNameLst>
+                                          <p:attrName>style.visibility</p:attrName>
+                                        </p:attrNameLst>
+                                      </p:cBhvr>
+                                      <p:to>
+                                        <p:strVal val="visible"/>
+                                      </p:to>
+                                    </p:set>
+                                    <p:animEffect transition="in" filter="fade">
+                                      <p:cBhvr>
+                                        <p:cTn id="7" dur="450"/>
+                                        <p:tgtEl>
+                                          <p:spTgt spid="251"/>
+                                        </p:tgtEl>
+                                      </p:cBhvr>
+                                    </p:animEffect>
+                                  </p:childTnLst>
+                                </p:cTn>
+                              </p:par>
+                              <p:par>
+                                <p:cTn id="8" presetID="10" presetClass="entr" presetSubtype="0" fill="hold" grpId="0" nodeType="withEffect">
+                                  <p:stCondLst>
+                                    <p:cond delay="150"/>
+                                  </p:stCondLst>
+                                  <p:childTnLst>
+                                    <p:set>
+                                      <p:cBhvr>
+                                        <p:cTn id="9" dur="1" fill="hold">
+                                          <p:stCondLst>
+                                            <p:cond delay="0"/>
+                                          </p:stCondLst>
+                                        </p:cTn>
+                                        <p:tgtEl>
+                                          <p:spTgt spid="252"/>
+                                        </p:tgtEl>
+                                        <p:attrNameLst>
+                                          <p:attrName>style.visibility</p:attrName>
+                                        </p:attrNameLst>
+                                      </p:cBhvr>
+                                      <p:to>
+                                        <p:strVal val="visible"/>
+                                      </p:to>
+                                    </p:set>
+                                    <p:animEffect transition="in" filter="fade">
+                                      <p:cBhvr>
+                                        <p:cTn id="10" dur="450"/>
+                                        <p:tgtEl>
+                                          <p:spTgt spid="252"/>
+                                        </p:tgtEl>
+                                      </p:cBhvr>
+                                    </p:animEffect>
+                                  </p:childTnLst>
+                                </p:cTn>
+                              </p:par>
+                              <p:par>
+                                <p:cTn id="11" presetID="10" presetClass="entr" presetSubtype="0" fill="hold" grpId="0" nodeType="withEffect">
+                                  <p:stCondLst>
+                                    <p:cond delay="150"/>
+                                  </p:stCondLst>
+                                  <p:childTnLst>
+                                    <p:set>
+                                      <p:cBhvr>
+                                        <p:cTn id="12" dur="1" fill="hold">
+                                          <p:stCondLst>
+                                            <p:cond delay="0"/>
+                                          </p:stCondLst>
+                                        </p:cTn>
+                                        <p:tgtEl>
+                                          <p:spTgt spid="253"/>
+                                        </p:tgtEl>
+                                        <p:attrNameLst>
+                                          <p:attrName>style.visibility</p:attrName>
+                                        </p:attrNameLst>
+                                      </p:cBhvr>
+                                      <p:to>
+                                        <p:strVal val="visible"/>
+                                      </p:to>
+                                    </p:set>
+                                    <p:animEffect transition="in" filter="fade">
+                                      <p:cBhvr>
+                                        <p:cTn id="13" dur="450"/>
+                                        <p:tgtEl>
+                                          <p:spTgt spid="253"/>
+                                        </p:tgtEl>
+                                      </p:cBhvr>
+                                    </p:animEffect>
+                                  </p:childTnLst>
+                                </p:cTn>
+                              </p:par>
+                              <p:par>
+                                <p:cTn id="14" presetID="10" presetClass="entr" presetSubtype="0" fill="hold" grpId="0" nodeType="withEffect">
+                                  <p:stCondLst>
+                                    <p:cond delay="150"/>
+                                  </p:stCondLst>
+                                  <p:childTnLst>
+                                    <p:set>
+                                      <p:cBhvr>
+                                        <p:cTn id="15" dur="1" fill="hold">
+                                          <p:stCondLst>
+                                            <p:cond delay="0"/>
+                                          </p:stCondLst>
+                                        </p:cTn>
+                                        <p:tgtEl>
+                                          <p:spTgt spid="254"/>
+                                        </p:tgtEl>
+                                        <p:attrNameLst>
+                                          <p:attrName>style.visibility</p:attrName>
+                                        </p:attrNameLst>
+                                      </p:cBhvr>
+                                      <p:to>
+                                        <p:strVal val="visible"/>
+                                      </p:to>
+                                    </p:set>
+                                    <p:animEffect transition="in" filter="fade">
+                                      <p:cBhvr>
+                                        <p:cTn id="16" dur="450"/>
+                                        <p:tgtEl>
+                                          <p:spTgt spid="254"/>
+                                        </p:tgtEl>
+                                      </p:cBhvr>
+                                    </p:animEffect>
+                                  </p:childTnLst>
+                                </p:cTn>
+                              </p:par>
+                              <p:par>
+                                <p:cTn id="17" presetID="10" presetClass="entr" presetSubtype="0" fill="hold" grpId="0" nodeType="withEffect">
+                                  <p:stCondLst>
+                                    <p:cond delay="330"/>
+                                  </p:stCondLst>
+                                  <p:childTnLst>
+                                    <p:set>
+                                      <p:cBhvr>
+                                        <p:cTn id="18" dur="1" fill="hold">
+                                          <p:stCondLst>
+                                            <p:cond delay="0"/>
+                                          </p:stCondLst>
+                                        </p:cTn>
+                                        <p:tgtEl>
+                                          <p:spTgt spid="255"/>
+                                        </p:tgtEl>
+                                        <p:attrNameLst>
+                                          <p:attrName>style.visibility</p:attrName>
+                                        </p:attrNameLst>
+                                      </p:cBhvr>
+                                      <p:to>
+                                        <p:strVal val="visible"/>
+                                      </p:to>
+                                    </p:set>
+                                    <p:animEffect transition="in" filter="fade">
+                                      <p:cBhvr>
+                                        <p:cTn id="19" dur="450"/>
+                                        <p:tgtEl>
+                                          <p:spTgt spid="255"/>
+                                        </p:tgtEl>
+                                      </p:cBhvr>
+                                    </p:animEffect>
+                                  </p:childTnLst>
+                                </p:cTn>
+                              </p:par>
+                              <p:par>
+                                <p:cTn id="20" presetID="10" presetClass="entr" presetSubtype="0" fill="hold" grpId="0" nodeType="withEffect">
+                                  <p:stCondLst>
+                                    <p:cond delay="330"/>
+                                  </p:stCondLst>
+                                  <p:childTnLst>
+                                    <p:set>
+                                      <p:cBhvr>
+                                        <p:cTn id="21" dur="1" fill="hold">
+                                          <p:stCondLst>
+                                            <p:cond delay="0"/>
+                                          </p:stCondLst>
+                                        </p:cTn>
+                                        <p:tgtEl>
+                                          <p:spTgt spid="256"/>
+                                        </p:tgtEl>
+                                        <p:attrNameLst>
+                                          <p:attrName>style.visibility</p:attrName>
+                                        </p:attrNameLst>
+                                      </p:cBhvr>
+                                      <p:to>
+                                        <p:strVal val="visible"/>
+                                      </p:to>
+                                    </p:set>
+                                    <p:animEffect transition="in" filter="fade">
+                                      <p:cBhvr>
+                                        <p:cTn id="22" dur="450"/>
+                                        <p:tgtEl>
+                                          <p:spTgt spid="256"/>
+                                        </p:tgtEl>
+                                      </p:cBhvr>
+                                    </p:animEffect>
+                                  </p:childTnLst>
+                                </p:cTn>
+                              </p:par>
+                              <p:par>
+                                <p:cTn id="23" presetID="10" presetClass="entr" presetSubtype="0" fill="hold" grpId="0" nodeType="withEffect">
+                                  <p:stCondLst>
+                                    <p:cond delay="330"/>
+                                  </p:stCondLst>
+                                  <p:childTnLst>
+                                    <p:set>
+                                      <p:cBhvr>
+                                        <p:cTn id="24" dur="1" fill="hold">
+                                          <p:stCondLst>
+                                            <p:cond delay="0"/>
+                                          </p:stCondLst>
+                                        </p:cTn>
+                                        <p:tgtEl>
+                                          <p:spTgt spid="257"/>
+                                        </p:tgtEl>
+                                        <p:attrNameLst>
+                                          <p:attrName>style.visibility</p:attrName>
+                                        </p:attrNameLst>
+                                      </p:cBhvr>
+                                      <p:to>
+                                        <p:strVal val="visible"/>
+                                      </p:to>
+                                    </p:set>
+                                    <p:animEffect transition="in" filter="fade">
+                                      <p:cBhvr>
+                                        <p:cTn id="25" dur="450"/>
+                                        <p:tgtEl>
+                                          <p:spTgt spid="257"/>
+                                        </p:tgtEl>
+                                      </p:cBhvr>
+                                    </p:animEffect>
+                                  </p:childTnLst>
+                                </p:cTn>
+                              </p:par>
+                              <p:par>
+                                <p:cTn id="26" presetID="10" presetClass="entr" presetSubtype="0" fill="hold" grpId="0" nodeType="withEffect">
+                                  <p:stCondLst>
+                                    <p:cond delay="330"/>
+                                  </p:stCondLst>
+                                  <p:childTnLst>
+                                    <p:set>
+                                      <p:cBhvr>
+                                        <p:cTn id="27" dur="1" fill="hold">
+                                          <p:stCondLst>
+                                            <p:cond delay="0"/>
+                                          </p:stCondLst>
+                                        </p:cTn>
+                                        <p:tgtEl>
+                                          <p:spTgt spid="258"/>
+                                        </p:tgtEl>
+                                        <p:attrNameLst>
+                                          <p:attrName>style.visibility</p:attrName>
+                                        </p:attrNameLst>
+                                      </p:cBhvr>
+                                      <p:to>
+                                        <p:strVal val="visible"/>
+                                      </p:to>
+                                    </p:set>
+                                    <p:animEffect transition="in" filter="fade">
+                                      <p:cBhvr>
+                                        <p:cTn id="28" dur="450"/>
+                                        <p:tgtEl>
+                                          <p:spTgt spid="258"/>
+                                        </p:tgtEl>
+                                      </p:cBhvr>
+                                    </p:animEffect>
+                                  </p:childTnLst>
+                                </p:cTn>
+                              </p:par>
+                              <p:par>
+                                <p:cTn id="29" presetID="10" presetClass="entr" presetSubtype="0" fill="hold" grpId="0" nodeType="withEffect">
+                                  <p:stCondLst>
+                                    <p:cond delay="510"/>
+                                  </p:stCondLst>
+                                  <p:childTnLst>
+                                    <p:set>
+                                      <p:cBhvr>
+                                        <p:cTn id="30" dur="1" fill="hold">
+                                          <p:stCondLst>
+                                            <p:cond delay="0"/>
+                                          </p:stCondLst>
+                                        </p:cTn>
+                                        <p:tgtEl>
+                                          <p:spTgt spid="259"/>
+                                        </p:tgtEl>
+                                        <p:attrNameLst>
+                                          <p:attrName>style.visibility</p:attrName>
+                                        </p:attrNameLst>
+                                      </p:cBhvr>
+                                      <p:to>
+                                        <p:strVal val="visible"/>
+                                      </p:to>
+                                    </p:set>
+                                    <p:animEffect transition="in" filter="fade">
+                                      <p:cBhvr>
+                                        <p:cTn id="31" dur="450"/>
+                                        <p:tgtEl>
+                                          <p:spTgt spid="259"/>
+                                        </p:tgtEl>
+                                      </p:cBhvr>
+                                    </p:animEffect>
+                                  </p:childTnLst>
+                                </p:cTn>
+                              </p:par>
+                              <p:par>
+                                <p:cTn id="32" presetID="10" presetClass="entr" presetSubtype="0" fill="hold" grpId="0" nodeType="withEffect">
+                                  <p:stCondLst>
+                                    <p:cond delay="510"/>
+                                  </p:stCondLst>
+                                  <p:childTnLst>
+                                    <p:set>
+                                      <p:cBhvr>
+                                        <p:cTn id="33" dur="1" fill="hold">
+                                          <p:stCondLst>
+                                            <p:cond delay="0"/>
+                                          </p:stCondLst>
+                                        </p:cTn>
+                                        <p:tgtEl>
+                                          <p:spTgt spid="260"/>
+                                        </p:tgtEl>
+                                        <p:attrNameLst>
+                                          <p:attrName>style.visibility</p:attrName>
+                                        </p:attrNameLst>
+                                      </p:cBhvr>
+                                      <p:to>
+                                        <p:strVal val="visible"/>
+                                      </p:to>
+                                    </p:set>
+                                    <p:animEffect transition="in" filter="fade">
+                                      <p:cBhvr>
+                                        <p:cTn id="34" dur="450"/>
+                                        <p:tgtEl>
+                                          <p:spTgt spid="260"/>
+                                        </p:tgtEl>
+                                      </p:cBhvr>
+                                    </p:animEffect>
+                                  </p:childTnLst>
+                                </p:cTn>
+                              </p:par>
+                              <p:par>
+                                <p:cTn id="35" presetID="10" presetClass="entr" presetSubtype="0" fill="hold" grpId="0" nodeType="withEffect">
+                                  <p:stCondLst>
+                                    <p:cond delay="510"/>
+                                  </p:stCondLst>
+                                  <p:childTnLst>
+                                    <p:set>
+                                      <p:cBhvr>
+                                        <p:cTn id="36" dur="1" fill="hold">
+                                          <p:stCondLst>
+                                            <p:cond delay="0"/>
+                                          </p:stCondLst>
+                                        </p:cTn>
+                                        <p:tgtEl>
+                                          <p:spTgt spid="261"/>
+                                        </p:tgtEl>
+                                        <p:attrNameLst>
+                                          <p:attrName>style.visibility</p:attrName>
+                                        </p:attrNameLst>
+                                      </p:cBhvr>
+                                      <p:to>
+                                        <p:strVal val="visible"/>
+                                      </p:to>
+                                    </p:set>
+                                    <p:animEffect transition="in" filter="fade">
+                                      <p:cBhvr>
+                                        <p:cTn id="37" dur="450"/>
+                                        <p:tgtEl>
+                                          <p:spTgt spid="261"/>
+                                        </p:tgtEl>
+                                      </p:cBhvr>
+                                    </p:animEffect>
+                                  </p:childTnLst>
+                                </p:cTn>
+                              </p:par>
+                              <p:par>
+                                <p:cTn id="38" presetID="10" presetClass="entr" presetSubtype="0" fill="hold" grpId="0" nodeType="withEffect">
+                                  <p:stCondLst>
+                                    <p:cond delay="510"/>
+                                  </p:stCondLst>
+                                  <p:childTnLst>
+                                    <p:set>
+                                      <p:cBhvr>
+                                        <p:cTn id="39" dur="1" fill="hold">
+                                          <p:stCondLst>
+                                            <p:cond delay="0"/>
+                                          </p:stCondLst>
+                                        </p:cTn>
+                                        <p:tgtEl>
+                                          <p:spTgt spid="262"/>
+                                        </p:tgtEl>
+                                        <p:attrNameLst>
+                                          <p:attrName>style.visibility</p:attrName>
+                                        </p:attrNameLst>
+                                      </p:cBhvr>
+                                      <p:to>
+                                        <p:strVal val="visible"/>
+                                      </p:to>
+                                    </p:set>
+                                    <p:animEffect transition="in" filter="fade">
+                                      <p:cBhvr>
+                                        <p:cTn id="40" dur="450"/>
+                                        <p:tgtEl>
+                                          <p:spTgt spid="262"/>
+                                        </p:tgtEl>
+                                      </p:cBhvr>
+                                    </p:animEffect>
+                                  </p:childTnLst>
+                                </p:cTn>
+                              </p:par>
+                              <p:par>
+                                <p:cTn id="41" presetID="10" presetClass="entr" presetSubtype="0" fill="hold" grpId="0" nodeType="withEffect">
+                                  <p:stCondLst>
+                                    <p:cond delay="690"/>
+                                  </p:stCondLst>
+                                  <p:childTnLst>
+                                    <p:set>
+                                      <p:cBhvr>
+                                        <p:cTn id="42" dur="1" fill="hold">
+                                          <p:stCondLst>
+                                            <p:cond delay="0"/>
+                                          </p:stCondLst>
+                                        </p:cTn>
+                                        <p:tgtEl>
+                                          <p:spTgt spid="263"/>
+                                        </p:tgtEl>
+                                        <p:attrNameLst>
+                                          <p:attrName>style.visibility</p:attrName>
+                                        </p:attrNameLst>
+                                      </p:cBhvr>
+                                      <p:to>
+                                        <p:strVal val="visible"/>
+                                      </p:to>
+                                    </p:set>
+                                    <p:animEffect transition="in" filter="fade">
+                                      <p:cBhvr>
+                                        <p:cTn id="43" dur="450"/>
+                                        <p:tgtEl>
+                                          <p:spTgt spid="263"/>
+                                        </p:tgtEl>
+                                      </p:cBhvr>
+                                    </p:animEffect>
+                                  </p:childTnLst>
+                                </p:cTn>
+                              </p:par>
+                              <p:par>
+                                <p:cTn id="44" presetID="10" presetClass="entr" presetSubtype="0" fill="hold" grpId="0" nodeType="withEffect">
+                                  <p:stCondLst>
+                                    <p:cond delay="690"/>
+                                  </p:stCondLst>
+                                  <p:childTnLst>
+                                    <p:set>
+                                      <p:cBhvr>
+                                        <p:cTn id="45" dur="1" fill="hold">
+                                          <p:stCondLst>
+                                            <p:cond delay="0"/>
+                                          </p:stCondLst>
+                                        </p:cTn>
+                                        <p:tgtEl>
+                                          <p:spTgt spid="264"/>
+                                        </p:tgtEl>
+                                        <p:attrNameLst>
+                                          <p:attrName>style.visibility</p:attrName>
+                                        </p:attrNameLst>
+                                      </p:cBhvr>
+                                      <p:to>
+                                        <p:strVal val="visible"/>
+                                      </p:to>
+                                    </p:set>
+                                    <p:animEffect transition="in" filter="fade">
+                                      <p:cBhvr>
+                                        <p:cTn id="46" dur="450"/>
+                                        <p:tgtEl>
+                                          <p:spTgt spid="264"/>
+                                        </p:tgtEl>
+                                      </p:cBhvr>
+                                    </p:animEffect>
+                                  </p:childTnLst>
+                                </p:cTn>
+                              </p:par>
+                              <p:par>
+                                <p:cTn id="47" presetID="10" presetClass="entr" presetSubtype="0" fill="hold" grpId="0" nodeType="withEffect">
+                                  <p:stCondLst>
+                                    <p:cond delay="690"/>
+                                  </p:stCondLst>
+                                  <p:childTnLst>
+                                    <p:set>
+                                      <p:cBhvr>
+                                        <p:cTn id="48" dur="1" fill="hold">
+                                          <p:stCondLst>
+                                            <p:cond delay="0"/>
+                                          </p:stCondLst>
+                                        </p:cTn>
+                                        <p:tgtEl>
+                                          <p:spTgt spid="265"/>
+                                        </p:tgtEl>
+                                        <p:attrNameLst>
+                                          <p:attrName>style.visibility</p:attrName>
+                                        </p:attrNameLst>
+                                      </p:cBhvr>
+                                      <p:to>
+                                        <p:strVal val="visible"/>
+                                      </p:to>
+                                    </p:set>
+                                    <p:animEffect transition="in" filter="fade">
+                                      <p:cBhvr>
+                                        <p:cTn id="49" dur="450"/>
+                                        <p:tgtEl>
+                                          <p:spTgt spid="265"/>
+                                        </p:tgtEl>
+                                      </p:cBhvr>
+                                    </p:animEffect>
+                                  </p:childTnLst>
+                                </p:cTn>
+                              </p:par>
+                              <p:par>
+                                <p:cTn id="50" presetID="10" presetClass="entr" presetSubtype="0" fill="hold" grpId="0" nodeType="withEffect">
+                                  <p:stCondLst>
+                                    <p:cond delay="690"/>
+                                  </p:stCondLst>
+                                  <p:childTnLst>
+                                    <p:set>
+                                      <p:cBhvr>
+                                        <p:cTn id="51" dur="1" fill="hold">
+                                          <p:stCondLst>
+                                            <p:cond delay="0"/>
+                                          </p:stCondLst>
+                                        </p:cTn>
+                                        <p:tgtEl>
+                                          <p:spTgt spid="266"/>
+                                        </p:tgtEl>
+                                        <p:attrNameLst>
+                                          <p:attrName>style.visibility</p:attrName>
+                                        </p:attrNameLst>
+                                      </p:cBhvr>
+                                      <p:to>
+                                        <p:strVal val="visible"/>
+                                      </p:to>
+                                    </p:set>
+                                    <p:animEffect transition="in" filter="fade">
+                                      <p:cBhvr>
+                                        <p:cTn id="52" dur="450"/>
+                                        <p:tgtEl>
+                                          <p:spTgt spid="266"/>
+                                        </p:tgtEl>
+                                      </p:cBhvr>
+                                    </p:animEffect>
+                                  </p:childTnLst>
+                                </p:cTn>
+                              </p:par>
+                            </p:childTnLst>
+                          </p:cTn>
+                        </p:par>
+                      </p:childTnLst>
+                    </p:cTn>
+                  </p:par>
+                </p:childTnLst>
+              </p:cTn>
+              <p:prevCondLst>
+                <p:cond evt="onPrev" delay="0">
+                  <p:tgtEl>
+                    <p:sldTgt/>
+                  </p:tgtEl>
+                </p:cond>
+              </p:prevCondLst>
+              <p:nextCondLst>
+                <p:cond evt="onNext" delay="0">
+                  <p:tgtEl>
+                    <p:sldTgt/>
+                  </p:tgtEl>
+                </p:cond>
+              </p:nextCondLst>
+            </p:seq>
+          </p:childTnLst>
+        </p:cTn>
+      </p:par>
+    </p:tnLst>
+    <p:bldLst>
+      <p:bldP spid="251" grpId="0" animBg="1"/>
+      <p:bldP spid="252" grpId="0"/>
+      <p:bldP spid="253" grpId="0"/>
+      <p:bldP spid="254" grpId="0"/>
+      <p:bldP spid="255" grpId="0" animBg="1"/>
+      <p:bldP spid="256" grpId="0"/>
+      <p:bldP spid="257" grpId="0"/>
+      <p:bldP spid="258" grpId="0"/>
+      <p:bldP spid="259" grpId="0" animBg="1"/>
+      <p:bldP spid="260" grpId="0"/>
+      <p:bldP spid="261" grpId="0"/>
+      <p:bldP spid="262" grpId="0"/>
+      <p:bldP spid="263" grpId="0" animBg="1"/>
+      <p:bldP spid="264" grpId="0"/>
+      <p:bldP spid="265" grpId="0"/>
+      <p:bldP spid="266" grpId="0"/>
+    </p:bldLst>
+  </p:timing>
 </p:sld>
 </file>
 
@@ -7168,8 +8275,8 @@
         </p:nvSpPr>
         <p:spPr>
           <a:xfrm>
-            <a:off x="320040" y="1543050"/>
-            <a:ext cx="5326500" cy="411600"/>
+            <a:off x="320040" y="1092200"/>
+            <a:ext cx="5326500" cy="965200"/>
           </a:xfrm>
           <a:prstGeom prst="rect">
             <a:avLst/>
@@ -7195,16 +8302,16 @@
               <a:buNone/>
             </a:pPr>
             <a:r>
-              <a:rPr lang="en" sz="1950" b="0">
+              <a:rPr lang="en" sz="5400" b="0">
                 <a:solidFill>
-                  <a:srgbClr val="CBD1DA"/>
+                  <a:srgbClr val="FFFFFF"/>
                 </a:solidFill>
-                <a:latin typeface="DM Sans"/>
-                <a:ea typeface="DM Sans"/>
-                <a:cs typeface="DM Sans"/>
-                <a:sym typeface="DM Sans"/>
+                <a:latin typeface="Sora SemiBold"/>
+                <a:ea typeface="Sora"/>
+                <a:cs typeface="Sora"/>
+                <a:sym typeface="Sora"/>
               </a:rPr>
-              <a:t>Stripe for forms.</a:t>
+              <a:t>Questions?</a:t>
             </a:r>
             <a:endParaRPr sz="1950" b="0">
               <a:solidFill>
@@ -7511,8 +8618,8 @@
         </p:blipFill>
         <p:spPr>
           <a:xfrm>
-            <a:off x="274320" y="635000"/>
-            <a:ext cx="2939862" cy="736600"/>
+            <a:off x="274320" y="431800"/>
+            <a:ext cx="2027491" cy="508000"/>
           </a:xfrm>
           <a:prstGeom prst="rect">
             <a:avLst/>
@@ -7524,6 +8631,9 @@
   <p:clrMapOvr>
     <a:masterClrMapping/>
   </p:clrMapOvr>
+  <p:transition spd="fast">
+    <p:fade/>
+  </p:transition>
 </p:sld>
 </file>
 
@@ -8675,6 +9785,9 @@
   <p:clrMapOvr>
     <a:masterClrMapping/>
   </p:clrMapOvr>
+  <p:transition spd="fast">
+    <p:fade/>
+  </p:transition>
 </p:sld>
 </file>
 
@@ -9225,6 +10338,9 @@
   <p:clrMapOvr>
     <a:masterClrMapping/>
   </p:clrMapOvr>
+  <p:transition spd="fast">
+    <p:fade/>
+  </p:transition>
 </p:sld>
 </file>
 
@@ -9289,8 +10405,8 @@
         </p:nvCxnSpPr>
         <p:spPr>
           <a:xfrm flipV="1">
-            <a:off x="1024441" y="1603407"/>
-            <a:ext cx="821908" cy="475842"/>
+            <a:off x="1287773" y="1598303"/>
+            <a:ext cx="1489995" cy="539142"/>
           </a:xfrm>
           <a:prstGeom prst="curvedConnector3">
             <a:avLst/>
@@ -9325,8 +10441,8 @@
         </p:nvCxnSpPr>
         <p:spPr>
           <a:xfrm>
-            <a:off x="2736850" y="1422400"/>
-            <a:ext cx="495300" cy="0"/>
+            <a:off x="3950970" y="1422400"/>
+            <a:ext cx="1267460" cy="0"/>
           </a:xfrm>
           <a:prstGeom prst="curvedConnector3">
             <a:avLst/>
@@ -9361,8 +10477,8 @@
         </p:nvCxnSpPr>
         <p:spPr>
           <a:xfrm>
-            <a:off x="3847388" y="1618689"/>
-            <a:ext cx="128423" cy="674221"/>
+            <a:off x="5965072" y="1617870"/>
+            <a:ext cx="205975" cy="675859"/>
           </a:xfrm>
           <a:prstGeom prst="curvedConnector3">
             <a:avLst/>
@@ -9397,8 +10513,8 @@
         </p:nvCxnSpPr>
         <p:spPr>
           <a:xfrm flipH="1">
-            <a:off x="2889250" y="2489200"/>
-            <a:ext cx="457200" cy="0"/>
+            <a:off x="4184650" y="2489200"/>
+            <a:ext cx="1252220" cy="0"/>
           </a:xfrm>
           <a:prstGeom prst="curvedConnector3">
             <a:avLst/>
@@ -9433,8 +10549,8 @@
         </p:nvCxnSpPr>
         <p:spPr>
           <a:xfrm flipH="1" flipV="1">
-            <a:off x="1069395" y="2312596"/>
-            <a:ext cx="613684" cy="89083"/>
+            <a:off x="1307889" y="2293303"/>
+            <a:ext cx="1441790" cy="130808"/>
           </a:xfrm>
           <a:prstGeom prst="curvedConnector3">
             <a:avLst/>
@@ -9469,8 +10585,8 @@
         </p:nvCxnSpPr>
         <p:spPr>
           <a:xfrm flipH="1">
-            <a:off x="1024441" y="1603407"/>
-            <a:ext cx="821908" cy="475842"/>
+            <a:off x="1287773" y="1598303"/>
+            <a:ext cx="1489995" cy="539142"/>
           </a:xfrm>
           <a:prstGeom prst="curvedConnector3">
             <a:avLst/>
@@ -9505,8 +10621,8 @@
         </p:nvCxnSpPr>
         <p:spPr>
           <a:xfrm>
-            <a:off x="1023844" y="2442976"/>
-            <a:ext cx="1205702" cy="703326"/>
+            <a:off x="1287474" y="2384578"/>
+            <a:ext cx="2103350" cy="766846"/>
           </a:xfrm>
           <a:prstGeom prst="curvedConnector3">
             <a:avLst/>
@@ -9541,8 +10657,8 @@
         </p:nvCxnSpPr>
         <p:spPr>
           <a:xfrm flipV="1">
-            <a:off x="2808058" y="1756720"/>
-            <a:ext cx="2032655" cy="1387678"/>
+            <a:off x="4289641" y="1685984"/>
+            <a:ext cx="3430782" cy="1463855"/>
           </a:xfrm>
           <a:prstGeom prst="curvedConnector3">
             <a:avLst/>
@@ -9577,8 +10693,8 @@
         </p:nvCxnSpPr>
         <p:spPr>
           <a:xfrm>
-            <a:off x="4321863" y="2670371"/>
-            <a:ext cx="558538" cy="327838"/>
+            <a:off x="6710477" y="2665234"/>
+            <a:ext cx="1061699" cy="389482"/>
           </a:xfrm>
           <a:prstGeom prst="curvedConnector3">
             <a:avLst/>
@@ -9613,8 +10729,8 @@
         </p:nvCxnSpPr>
         <p:spPr>
           <a:xfrm>
-            <a:off x="4387763" y="1465197"/>
-            <a:ext cx="382214" cy="28312"/>
+            <a:off x="6592536" y="1454207"/>
+            <a:ext cx="1095215" cy="50704"/>
           </a:xfrm>
           <a:prstGeom prst="curvedConnector3">
             <a:avLst/>
@@ -9649,7 +10765,7 @@
         </p:nvSpPr>
         <p:spPr>
           <a:xfrm>
-            <a:off x="381000" y="1930400"/>
+            <a:off x="617219" y="1930400"/>
             <a:ext cx="660400" cy="660400"/>
           </a:xfrm>
           <a:prstGeom prst="ellipse">
@@ -9693,7 +10809,7 @@
         </p:nvSpPr>
         <p:spPr>
           <a:xfrm>
-            <a:off x="304800" y="1930400"/>
+            <a:off x="541019" y="1930400"/>
             <a:ext cx="812800" cy="660400"/>
           </a:xfrm>
           <a:prstGeom prst="rect">
@@ -9728,8 +10844,8 @@
         </p:nvSpPr>
         <p:spPr>
           <a:xfrm>
-            <a:off x="1612900" y="1257300"/>
-            <a:ext cx="1092200" cy="330200"/>
+            <a:off x="2608580" y="1257300"/>
+            <a:ext cx="1310640" cy="330200"/>
           </a:xfrm>
           <a:prstGeom prst="rect">
             <a:avLst/>
@@ -9774,8 +10890,8 @@
         </p:nvSpPr>
         <p:spPr>
           <a:xfrm>
-            <a:off x="1536700" y="1257300"/>
-            <a:ext cx="1244600" cy="330200"/>
+            <a:off x="2532380" y="1257300"/>
+            <a:ext cx="1463040" cy="330200"/>
           </a:xfrm>
           <a:prstGeom prst="rect">
             <a:avLst/>
@@ -9809,8 +10925,8 @@
         </p:nvSpPr>
         <p:spPr>
           <a:xfrm>
-            <a:off x="3263900" y="1257300"/>
-            <a:ext cx="1092200" cy="330200"/>
+            <a:off x="5250180" y="1257300"/>
+            <a:ext cx="1310640" cy="330200"/>
           </a:xfrm>
           <a:prstGeom prst="rect">
             <a:avLst/>
@@ -9855,8 +10971,8 @@
         </p:nvSpPr>
         <p:spPr>
           <a:xfrm>
-            <a:off x="3187700" y="1257300"/>
-            <a:ext cx="1244600" cy="330200"/>
+            <a:off x="5173980" y="1257300"/>
+            <a:ext cx="1463040" cy="330200"/>
           </a:xfrm>
           <a:prstGeom prst="rect">
             <a:avLst/>
@@ -9890,8 +11006,8 @@
         </p:nvSpPr>
         <p:spPr>
           <a:xfrm>
-            <a:off x="1714500" y="2324100"/>
-            <a:ext cx="1143000" cy="330200"/>
+            <a:off x="2781300" y="2324100"/>
+            <a:ext cx="1371600" cy="330200"/>
           </a:xfrm>
           <a:prstGeom prst="rect">
             <a:avLst/>
@@ -9936,8 +11052,8 @@
         </p:nvSpPr>
         <p:spPr>
           <a:xfrm>
-            <a:off x="1638300" y="2324100"/>
-            <a:ext cx="1295400" cy="330200"/>
+            <a:off x="2705100" y="2324100"/>
+            <a:ext cx="1524000" cy="330200"/>
           </a:xfrm>
           <a:prstGeom prst="rect">
             <a:avLst/>
@@ -9971,8 +11087,8 @@
         </p:nvSpPr>
         <p:spPr>
           <a:xfrm>
-            <a:off x="3378200" y="2324100"/>
-            <a:ext cx="1270000" cy="330200"/>
+            <a:off x="5468620" y="2324100"/>
+            <a:ext cx="1524000" cy="330200"/>
           </a:xfrm>
           <a:prstGeom prst="rect">
             <a:avLst/>
@@ -10017,8 +11133,8 @@
         </p:nvSpPr>
         <p:spPr>
           <a:xfrm>
-            <a:off x="3302000" y="2324100"/>
-            <a:ext cx="1422400" cy="330200"/>
+            <a:off x="5392420" y="2324100"/>
+            <a:ext cx="1676400" cy="330200"/>
           </a:xfrm>
           <a:prstGeom prst="rect">
             <a:avLst/>
@@ -10052,8 +11168,8 @@
         </p:nvSpPr>
         <p:spPr>
           <a:xfrm>
-            <a:off x="1879600" y="3162300"/>
-            <a:ext cx="1320800" cy="330200"/>
+            <a:off x="3081020" y="3162300"/>
+            <a:ext cx="1584960" cy="330200"/>
           </a:xfrm>
           <a:prstGeom prst="rect">
             <a:avLst/>
@@ -10098,8 +11214,8 @@
         </p:nvSpPr>
         <p:spPr>
           <a:xfrm>
-            <a:off x="1803400" y="3162300"/>
-            <a:ext cx="1473200" cy="330200"/>
+            <a:off x="3004820" y="3162300"/>
+            <a:ext cx="1737360" cy="330200"/>
           </a:xfrm>
           <a:prstGeom prst="rect">
             <a:avLst/>
@@ -10133,7 +11249,7 @@
         </p:nvSpPr>
         <p:spPr>
           <a:xfrm>
-            <a:off x="4800600" y="1143000"/>
+            <a:off x="7719060" y="1143000"/>
             <a:ext cx="762000" cy="762000"/>
           </a:xfrm>
           <a:prstGeom prst="ellipse">
@@ -10180,7 +11296,7 @@
         </p:nvSpPr>
         <p:spPr>
           <a:xfrm>
-            <a:off x="4724400" y="1143000"/>
+            <a:off x="7642860" y="1143000"/>
             <a:ext cx="914400" cy="762000"/>
           </a:xfrm>
           <a:prstGeom prst="rect">
@@ -10215,7 +11331,7 @@
         </p:nvSpPr>
         <p:spPr>
           <a:xfrm>
-            <a:off x="4864100" y="2857500"/>
+            <a:off x="7782560" y="2857500"/>
             <a:ext cx="635000" cy="635000"/>
           </a:xfrm>
           <a:prstGeom prst="ellipse">
@@ -10259,7 +11375,7 @@
         </p:nvSpPr>
         <p:spPr>
           <a:xfrm>
-            <a:off x="4787900" y="2857500"/>
+            <a:off x="7706360" y="2857500"/>
             <a:ext cx="787400" cy="635000"/>
           </a:xfrm>
           <a:prstGeom prst="rect">
@@ -10444,7 +11560,7 @@
         <p:spPr>
           <a:xfrm>
             <a:off x="1016000" y="4267200"/>
-            <a:ext cx="254000" cy="0"/>
+            <a:ext cx="304800" cy="0"/>
           </a:xfrm>
           <a:prstGeom prst="line">
             <a:avLst/>
@@ -10479,8 +11595,8 @@
         </p:nvSpPr>
         <p:spPr>
           <a:xfrm>
-            <a:off x="1320800" y="4076700"/>
-            <a:ext cx="1905000" cy="381000"/>
+            <a:off x="1371600" y="4051300"/>
+            <a:ext cx="2260600" cy="431800"/>
           </a:xfrm>
           <a:prstGeom prst="roundRect">
             <a:avLst>
@@ -10533,8 +11649,8 @@
         </p:blipFill>
         <p:spPr>
           <a:xfrm>
-            <a:off x="1473200" y="4159250"/>
-            <a:ext cx="183962" cy="215900"/>
+            <a:off x="1549400" y="4140200"/>
+            <a:ext cx="216426" cy="254000"/>
           </a:xfrm>
           <a:prstGeom prst="rect">
             <a:avLst/>
@@ -10549,8 +11665,8 @@
         </p:nvSpPr>
         <p:spPr>
           <a:xfrm>
-            <a:off x="1676400" y="4076700"/>
-            <a:ext cx="1524000" cy="381000"/>
+            <a:off x="1803400" y="4051300"/>
+            <a:ext cx="1778000" cy="431800"/>
           </a:xfrm>
           <a:prstGeom prst="rect">
             <a:avLst/>
@@ -10565,7 +11681,7 @@
           <a:p>
             <a:pPr algn="l"/>
             <a:r>
-              <a:rPr sz="1100" b="0">
+              <a:rPr sz="1250" b="0">
                 <a:solidFill>
                   <a:srgbClr val="FFFFFF"/>
                 </a:solidFill>
@@ -10584,8 +11700,8 @@
         </p:nvCxnSpPr>
         <p:spPr>
           <a:xfrm>
-            <a:off x="3276600" y="4267200"/>
-            <a:ext cx="533400" cy="0"/>
+            <a:off x="3708400" y="4267200"/>
+            <a:ext cx="3606800" cy="0"/>
           </a:xfrm>
           <a:prstGeom prst="line">
             <a:avLst/>
@@ -10620,8 +11736,8 @@
         </p:nvSpPr>
         <p:spPr>
           <a:xfrm>
-            <a:off x="3860800" y="4076700"/>
-            <a:ext cx="1219200" cy="381000"/>
+            <a:off x="7391400" y="4051300"/>
+            <a:ext cx="1397000" cy="431800"/>
           </a:xfrm>
           <a:prstGeom prst="roundRect">
             <a:avLst>
@@ -10666,8 +11782,8 @@
         </p:nvSpPr>
         <p:spPr>
           <a:xfrm>
-            <a:off x="3860800" y="4076700"/>
-            <a:ext cx="1219200" cy="381000"/>
+            <a:off x="7391400" y="4051300"/>
+            <a:ext cx="1397000" cy="431800"/>
           </a:xfrm>
           <a:prstGeom prst="rect">
             <a:avLst/>
@@ -10682,7 +11798,7 @@
           <a:p>
             <a:pPr algn="ctr"/>
             <a:r>
-              <a:rPr sz="1100" b="0">
+              <a:rPr sz="1250" b="0">
                 <a:solidFill>
                   <a:srgbClr val="0F1A2A"/>
                 </a:solidFill>
@@ -10693,274 +11809,421 @@
           </a:p>
         </p:txBody>
       </p:sp>
-      <p:sp>
-        <p:nvSpPr>
-          <p:cNvPr id="40" name="TextBox 39"/>
-          <p:cNvSpPr txBox="1"/>
-          <p:nvPr/>
-        </p:nvSpPr>
-        <p:spPr>
-          <a:xfrm>
-            <a:off x="5918200" y="1168400"/>
-            <a:ext cx="2921000" cy="635000"/>
-          </a:xfrm>
-          <a:prstGeom prst="rect">
-            <a:avLst/>
-          </a:prstGeom>
-          <a:noFill/>
-        </p:spPr>
-        <p:txBody>
-          <a:bodyPr wrap="square" anchor="t" lIns="45720" rIns="45720">
-            <a:spAutoFit/>
-          </a:bodyPr>
-          <a:lstStyle/>
-          <a:p>
-            <a:pPr algn="l"/>
-            <a:r>
-              <a:rPr sz="3600" b="0">
-                <a:solidFill>
-                  <a:srgbClr val="0F1A2A"/>
-                </a:solidFill>
-                <a:latin typeface="Sora SemiBold"/>
-              </a:rPr>
-              <a:t>$1,835</a:t>
-            </a:r>
-          </a:p>
-        </p:txBody>
-      </p:sp>
-      <p:sp>
-        <p:nvSpPr>
-          <p:cNvPr id="41" name="TextBox 40"/>
-          <p:cNvSpPr txBox="1"/>
-          <p:nvPr/>
-        </p:nvSpPr>
-        <p:spPr>
-          <a:xfrm>
-            <a:off x="5918200" y="1752600"/>
-            <a:ext cx="2921000" cy="635000"/>
-          </a:xfrm>
-          <a:prstGeom prst="rect">
-            <a:avLst/>
-          </a:prstGeom>
-          <a:noFill/>
-        </p:spPr>
-        <p:txBody>
-          <a:bodyPr wrap="square" anchor="t" lIns="45720" rIns="45720">
-            <a:spAutoFit/>
-          </a:bodyPr>
-          <a:lstStyle/>
-          <a:p>
-            <a:pPr algn="l"/>
-            <a:r>
-              <a:rPr sz="1100" b="0">
-                <a:solidFill>
-                  <a:srgbClr val="5B6575"/>
-                </a:solidFill>
-                <a:latin typeface="DM Sans"/>
-              </a:rPr>
-              <a:t>a year from each new account that finishes signing up ($152.91 a month).</a:t>
-            </a:r>
-          </a:p>
-        </p:txBody>
-      </p:sp>
-      <p:sp>
-        <p:nvSpPr>
-          <p:cNvPr id="42" name="Rectangle 41"/>
-          <p:cNvSpPr/>
-          <p:nvPr/>
-        </p:nvSpPr>
-        <p:spPr>
-          <a:xfrm>
-            <a:off x="5969000" y="2463800"/>
-            <a:ext cx="2667000" cy="12700"/>
-          </a:xfrm>
-          <a:prstGeom prst="rect">
-            <a:avLst/>
-          </a:prstGeom>
-          <a:solidFill>
-            <a:srgbClr val="CBD1DA"/>
-          </a:solidFill>
-          <a:ln>
-            <a:noFill/>
-          </a:ln>
-          <a:effectLst/>
-        </p:spPr>
-        <p:style>
-          <a:lnRef idx="1">
-            <a:schemeClr val="accent1"/>
-          </a:lnRef>
-          <a:fillRef idx="3">
-            <a:schemeClr val="accent1"/>
-          </a:fillRef>
-          <a:effectRef idx="2">
-            <a:schemeClr val="accent1"/>
-          </a:effectRef>
-          <a:fontRef idx="minor">
-            <a:schemeClr val="lt1"/>
-          </a:fontRef>
-        </p:style>
-        <p:txBody>
-          <a:bodyPr rtlCol="0" anchor="ctr"/>
-          <a:lstStyle/>
-          <a:p>
-            <a:pPr algn="ctr"/>
-          </a:p>
-        </p:txBody>
-      </p:sp>
-      <p:sp>
-        <p:nvSpPr>
-          <p:cNvPr id="43" name="TextBox 42"/>
-          <p:cNvSpPr txBox="1"/>
-          <p:nvPr/>
-        </p:nvSpPr>
-        <p:spPr>
-          <a:xfrm>
-            <a:off x="5918200" y="2565400"/>
-            <a:ext cx="2921000" cy="558800"/>
-          </a:xfrm>
-          <a:prstGeom prst="rect">
-            <a:avLst/>
-          </a:prstGeom>
-          <a:noFill/>
-        </p:spPr>
-        <p:txBody>
-          <a:bodyPr wrap="square" anchor="t" lIns="45720" rIns="45720">
-            <a:spAutoFit/>
-          </a:bodyPr>
-          <a:lstStyle/>
-          <a:p>
-            <a:pPr algn="l"/>
-            <a:r>
-              <a:rPr sz="2800" b="0">
-                <a:solidFill>
-                  <a:srgbClr val="0F1A2A"/>
-                </a:solidFill>
-                <a:latin typeface="Sora SemiBold"/>
-              </a:rPr>
-              <a:t>up to 50%</a:t>
-            </a:r>
-          </a:p>
-        </p:txBody>
-      </p:sp>
-      <p:sp>
-        <p:nvSpPr>
-          <p:cNvPr id="44" name="TextBox 43"/>
-          <p:cNvSpPr txBox="1"/>
-          <p:nvPr/>
-        </p:nvSpPr>
-        <p:spPr>
-          <a:xfrm>
-            <a:off x="5918200" y="3048000"/>
-            <a:ext cx="2921000" cy="635000"/>
-          </a:xfrm>
-          <a:prstGeom prst="rect">
-            <a:avLst/>
-          </a:prstGeom>
-          <a:noFill/>
-        </p:spPr>
-        <p:txBody>
-          <a:bodyPr wrap="square" anchor="t" lIns="45720" rIns="45720">
-            <a:spAutoFit/>
-          </a:bodyPr>
-          <a:lstStyle/>
-          <a:p>
-            <a:pPr algn="l"/>
-            <a:r>
-              <a:rPr sz="1100" b="0">
-                <a:solidFill>
-                  <a:srgbClr val="5B6575"/>
-                </a:solidFill>
-                <a:latin typeface="DM Sans"/>
-              </a:rPr>
-              <a:t>more checkouts finished when the form is prefilled (Shop Pay vs. guest checkout).</a:t>
-            </a:r>
-          </a:p>
-        </p:txBody>
-      </p:sp>
-      <p:sp>
-        <p:nvSpPr>
-          <p:cNvPr id="45" name="TextBox 44"/>
-          <p:cNvSpPr txBox="1"/>
-          <p:nvPr/>
-        </p:nvSpPr>
-        <p:spPr>
-          <a:xfrm>
-            <a:off x="5918200" y="3810000"/>
-            <a:ext cx="2921000" cy="508000"/>
-          </a:xfrm>
-          <a:prstGeom prst="rect">
-            <a:avLst/>
-          </a:prstGeom>
-          <a:noFill/>
-        </p:spPr>
-        <p:txBody>
-          <a:bodyPr wrap="square" anchor="t" lIns="45720" rIns="45720">
-            <a:spAutoFit/>
-          </a:bodyPr>
-          <a:lstStyle/>
-          <a:p>
-            <a:pPr algn="l"/>
-            <a:r>
-              <a:rPr sz="850" b="0">
-                <a:solidFill>
-                  <a:srgbClr val="8A94A3"/>
-                </a:solidFill>
-                <a:latin typeface="DM Sans"/>
-              </a:rPr>
-              <a:t>Sources: T-Mobile Q2 2026 results, postpaid ARPA</a:t>
-            </a:r>
-          </a:p>
-        </p:txBody>
-      </p:sp>
-      <p:sp>
-        <p:nvSpPr>
-          <p:cNvPr id="46" name="Rectangle 45"/>
-          <p:cNvSpPr/>
-          <p:nvPr/>
-        </p:nvSpPr>
-        <p:spPr>
-          <a:xfrm>
-            <a:off x="5791200" y="1244600"/>
-            <a:ext cx="63500" cy="1168400"/>
-          </a:xfrm>
-          <a:prstGeom prst="rect">
-            <a:avLst/>
-          </a:prstGeom>
-          <a:solidFill>
-            <a:srgbClr val="22C985"/>
-          </a:solidFill>
-          <a:ln>
-            <a:noFill/>
-          </a:ln>
-          <a:effectLst/>
-        </p:spPr>
-        <p:style>
-          <a:lnRef idx="1">
-            <a:schemeClr val="accent1"/>
-          </a:lnRef>
-          <a:fillRef idx="3">
-            <a:schemeClr val="accent1"/>
-          </a:fillRef>
-          <a:effectRef idx="2">
-            <a:schemeClr val="accent1"/>
-          </a:effectRef>
-          <a:fontRef idx="minor">
-            <a:schemeClr val="lt1"/>
-          </a:fontRef>
-        </p:style>
-        <p:txBody>
-          <a:bodyPr rtlCol="0" anchor="ctr"/>
-          <a:lstStyle/>
-          <a:p>
-            <a:pPr algn="ctr"/>
-          </a:p>
-        </p:txBody>
-      </p:sp>
     </p:spTree>
   </p:cSld>
   <p:clrMapOvr>
     <a:masterClrMapping/>
   </p:clrMapOvr>
+  <p:transition spd="fast">
+    <p:fade/>
+  </p:transition>
+  <p:timing>
+    <p:tnLst>
+      <p:par>
+        <p:cTn id="1" dur="indefinite" restart="never" nodeType="tmRoot">
+          <p:childTnLst>
+            <p:seq concurrent="1" nextAc="seek">
+              <p:cTn id="2" dur="indefinite" nodeType="mainSeq">
+                <p:childTnLst>
+                  <p:par>
+                    <p:cTn id="3" fill="hold">
+                      <p:stCondLst>
+                        <p:cond delay="indefinite"/>
+                      </p:stCondLst>
+                      <p:childTnLst>
+                        <p:par>
+                          <p:cTn id="4" fill="hold">
+                            <p:stCondLst>
+                              <p:cond delay="0"/>
+                            </p:stCondLst>
+                            <p:childTnLst>
+                              <p:par>
+                                <p:cTn id="5" presetID="10" presetClass="entr" presetSubtype="0" fill="hold" grpId="0" nodeType="clickEffect">
+                                  <p:stCondLst>
+                                    <p:cond delay="0"/>
+                                  </p:stCondLst>
+                                  <p:childTnLst>
+                                    <p:set>
+                                      <p:cBhvr>
+                                        <p:cTn id="6" dur="1" fill="hold">
+                                          <p:stCondLst>
+                                            <p:cond delay="0"/>
+                                          </p:stCondLst>
+                                        </p:cTn>
+                                        <p:tgtEl>
+                                          <p:spTgt spid="30"/>
+                                        </p:tgtEl>
+                                        <p:attrNameLst>
+                                          <p:attrName>style.visibility</p:attrName>
+                                        </p:attrNameLst>
+                                      </p:cBhvr>
+                                      <p:to>
+                                        <p:strVal val="visible"/>
+                                      </p:to>
+                                    </p:set>
+                                    <p:animEffect transition="in" filter="fade">
+                                      <p:cBhvr>
+                                        <p:cTn id="7" dur="450"/>
+                                        <p:tgtEl>
+                                          <p:spTgt spid="30"/>
+                                        </p:tgtEl>
+                                      </p:cBhvr>
+                                    </p:animEffect>
+                                  </p:childTnLst>
+                                </p:cTn>
+                              </p:par>
+                              <p:par>
+                                <p:cTn id="8" presetID="10" presetClass="entr" presetSubtype="0" fill="hold" grpId="0" nodeType="withEffect">
+                                  <p:stCondLst>
+                                    <p:cond delay="0"/>
+                                  </p:stCondLst>
+                                  <p:childTnLst>
+                                    <p:set>
+                                      <p:cBhvr>
+                                        <p:cTn id="9" dur="1" fill="hold">
+                                          <p:stCondLst>
+                                            <p:cond delay="0"/>
+                                          </p:stCondLst>
+                                        </p:cTn>
+                                        <p:tgtEl>
+                                          <p:spTgt spid="31"/>
+                                        </p:tgtEl>
+                                        <p:attrNameLst>
+                                          <p:attrName>style.visibility</p:attrName>
+                                        </p:attrNameLst>
+                                      </p:cBhvr>
+                                      <p:to>
+                                        <p:strVal val="visible"/>
+                                      </p:to>
+                                    </p:set>
+                                    <p:animEffect transition="in" filter="fade">
+                                      <p:cBhvr>
+                                        <p:cTn id="10" dur="450"/>
+                                        <p:tgtEl>
+                                          <p:spTgt spid="31"/>
+                                        </p:tgtEl>
+                                      </p:cBhvr>
+                                    </p:animEffect>
+                                  </p:childTnLst>
+                                </p:cTn>
+                              </p:par>
+                              <p:par>
+                                <p:cTn id="11" presetID="10" presetClass="entr" presetSubtype="0" fill="hold" grpId="0" nodeType="withEffect">
+                                  <p:stCondLst>
+                                    <p:cond delay="0"/>
+                                  </p:stCondLst>
+                                  <p:childTnLst>
+                                    <p:set>
+                                      <p:cBhvr>
+                                        <p:cTn id="12" dur="1" fill="hold">
+                                          <p:stCondLst>
+                                            <p:cond delay="0"/>
+                                          </p:stCondLst>
+                                        </p:cTn>
+                                        <p:tgtEl>
+                                          <p:spTgt spid="32"/>
+                                        </p:tgtEl>
+                                        <p:attrNameLst>
+                                          <p:attrName>style.visibility</p:attrName>
+                                        </p:attrNameLst>
+                                      </p:cBhvr>
+                                      <p:to>
+                                        <p:strVal val="visible"/>
+                                      </p:to>
+                                    </p:set>
+                                    <p:animEffect transition="in" filter="fade">
+                                      <p:cBhvr>
+                                        <p:cTn id="13" dur="450"/>
+                                        <p:tgtEl>
+                                          <p:spTgt spid="32"/>
+                                        </p:tgtEl>
+                                      </p:cBhvr>
+                                    </p:animEffect>
+                                  </p:childTnLst>
+                                </p:cTn>
+                              </p:par>
+                              <p:par>
+                                <p:cTn id="14" presetID="10" presetClass="entr" presetSubtype="0" fill="hold" grpId="0" nodeType="withEffect">
+                                  <p:stCondLst>
+                                    <p:cond delay="0"/>
+                                  </p:stCondLst>
+                                  <p:childTnLst>
+                                    <p:set>
+                                      <p:cBhvr>
+                                        <p:cTn id="15" dur="1" fill="hold">
+                                          <p:stCondLst>
+                                            <p:cond delay="0"/>
+                                          </p:stCondLst>
+                                        </p:cTn>
+                                        <p:tgtEl>
+                                          <p:spTgt spid="33"/>
+                                        </p:tgtEl>
+                                        <p:attrNameLst>
+                                          <p:attrName>style.visibility</p:attrName>
+                                        </p:attrNameLst>
+                                      </p:cBhvr>
+                                      <p:to>
+                                        <p:strVal val="visible"/>
+                                      </p:to>
+                                    </p:set>
+                                    <p:animEffect transition="in" filter="fade">
+                                      <p:cBhvr>
+                                        <p:cTn id="16" dur="450"/>
+                                        <p:tgtEl>
+                                          <p:spTgt spid="33"/>
+                                        </p:tgtEl>
+                                      </p:cBhvr>
+                                    </p:animEffect>
+                                  </p:childTnLst>
+                                </p:cTn>
+                              </p:par>
+                              <p:par>
+                                <p:cTn id="17" presetID="10" presetClass="entr" presetSubtype="0" fill="hold" grpId="0" nodeType="withEffect">
+                                  <p:stCondLst>
+                                    <p:cond delay="0"/>
+                                  </p:stCondLst>
+                                  <p:childTnLst>
+                                    <p:set>
+                                      <p:cBhvr>
+                                        <p:cTn id="18" dur="1" fill="hold">
+                                          <p:stCondLst>
+                                            <p:cond delay="0"/>
+                                          </p:stCondLst>
+                                        </p:cTn>
+                                        <p:tgtEl>
+                                          <p:spTgt spid="34"/>
+                                        </p:tgtEl>
+                                        <p:attrNameLst>
+                                          <p:attrName>style.visibility</p:attrName>
+                                        </p:attrNameLst>
+                                      </p:cBhvr>
+                                      <p:to>
+                                        <p:strVal val="visible"/>
+                                      </p:to>
+                                    </p:set>
+                                    <p:animEffect transition="in" filter="fade">
+                                      <p:cBhvr>
+                                        <p:cTn id="19" dur="450"/>
+                                        <p:tgtEl>
+                                          <p:spTgt spid="34"/>
+                                        </p:tgtEl>
+                                      </p:cBhvr>
+                                    </p:animEffect>
+                                  </p:childTnLst>
+                                </p:cTn>
+                              </p:par>
+                              <p:par>
+                                <p:cTn id="20" presetID="10" presetClass="entr" presetSubtype="0" fill="hold" grpId="0" nodeType="withEffect">
+                                  <p:stCondLst>
+                                    <p:cond delay="0"/>
+                                  </p:stCondLst>
+                                  <p:childTnLst>
+                                    <p:set>
+                                      <p:cBhvr>
+                                        <p:cTn id="21" dur="1" fill="hold">
+                                          <p:stCondLst>
+                                            <p:cond delay="0"/>
+                                          </p:stCondLst>
+                                        </p:cTn>
+                                        <p:tgtEl>
+                                          <p:spTgt spid="35"/>
+                                        </p:tgtEl>
+                                        <p:attrNameLst>
+                                          <p:attrName>style.visibility</p:attrName>
+                                        </p:attrNameLst>
+                                      </p:cBhvr>
+                                      <p:to>
+                                        <p:strVal val="visible"/>
+                                      </p:to>
+                                    </p:set>
+                                    <p:animEffect transition="in" filter="fade">
+                                      <p:cBhvr>
+                                        <p:cTn id="22" dur="450"/>
+                                        <p:tgtEl>
+                                          <p:spTgt spid="35"/>
+                                        </p:tgtEl>
+                                      </p:cBhvr>
+                                    </p:animEffect>
+                                  </p:childTnLst>
+                                </p:cTn>
+                              </p:par>
+                              <p:par>
+                                <p:cTn id="23" presetID="10" presetClass="entr" presetSubtype="0" fill="hold" grpId="0" nodeType="withEffect">
+                                  <p:stCondLst>
+                                    <p:cond delay="0"/>
+                                  </p:stCondLst>
+                                  <p:childTnLst>
+                                    <p:set>
+                                      <p:cBhvr>
+                                        <p:cTn id="24" dur="1" fill="hold">
+                                          <p:stCondLst>
+                                            <p:cond delay="0"/>
+                                          </p:stCondLst>
+                                        </p:cTn>
+                                        <p:tgtEl>
+                                          <p:spTgt spid="36"/>
+                                        </p:tgtEl>
+                                        <p:attrNameLst>
+                                          <p:attrName>style.visibility</p:attrName>
+                                        </p:attrNameLst>
+                                      </p:cBhvr>
+                                      <p:to>
+                                        <p:strVal val="visible"/>
+                                      </p:to>
+                                    </p:set>
+                                    <p:animEffect transition="in" filter="fade">
+                                      <p:cBhvr>
+                                        <p:cTn id="25" dur="450"/>
+                                        <p:tgtEl>
+                                          <p:spTgt spid="36"/>
+                                        </p:tgtEl>
+                                      </p:cBhvr>
+                                    </p:animEffect>
+                                  </p:childTnLst>
+                                </p:cTn>
+                              </p:par>
+                              <p:par>
+                                <p:cTn id="26" presetID="10" presetClass="entr" presetSubtype="0" fill="hold" grpId="0" nodeType="withEffect">
+                                  <p:stCondLst>
+                                    <p:cond delay="0"/>
+                                  </p:stCondLst>
+                                  <p:childTnLst>
+                                    <p:set>
+                                      <p:cBhvr>
+                                        <p:cTn id="27" dur="1" fill="hold">
+                                          <p:stCondLst>
+                                            <p:cond delay="0"/>
+                                          </p:stCondLst>
+                                        </p:cTn>
+                                        <p:tgtEl>
+                                          <p:spTgt spid="37"/>
+                                        </p:tgtEl>
+                                        <p:attrNameLst>
+                                          <p:attrName>style.visibility</p:attrName>
+                                        </p:attrNameLst>
+                                      </p:cBhvr>
+                                      <p:to>
+                                        <p:strVal val="visible"/>
+                                      </p:to>
+                                    </p:set>
+                                    <p:animEffect transition="in" filter="fade">
+                                      <p:cBhvr>
+                                        <p:cTn id="28" dur="450"/>
+                                        <p:tgtEl>
+                                          <p:spTgt spid="37"/>
+                                        </p:tgtEl>
+                                      </p:cBhvr>
+                                    </p:animEffect>
+                                  </p:childTnLst>
+                                </p:cTn>
+                              </p:par>
+                              <p:par>
+                                <p:cTn id="29" presetID="10" presetClass="entr" presetSubtype="0" fill="hold" grpId="0" nodeType="withEffect">
+                                  <p:stCondLst>
+                                    <p:cond delay="0"/>
+                                  </p:stCondLst>
+                                  <p:childTnLst>
+                                    <p:set>
+                                      <p:cBhvr>
+                                        <p:cTn id="30" dur="1" fill="hold">
+                                          <p:stCondLst>
+                                            <p:cond delay="0"/>
+                                          </p:stCondLst>
+                                        </p:cTn>
+                                        <p:tgtEl>
+                                          <p:spTgt spid="38"/>
+                                        </p:tgtEl>
+                                        <p:attrNameLst>
+                                          <p:attrName>style.visibility</p:attrName>
+                                        </p:attrNameLst>
+                                      </p:cBhvr>
+                                      <p:to>
+                                        <p:strVal val="visible"/>
+                                      </p:to>
+                                    </p:set>
+                                    <p:animEffect transition="in" filter="fade">
+                                      <p:cBhvr>
+                                        <p:cTn id="31" dur="450"/>
+                                        <p:tgtEl>
+                                          <p:spTgt spid="38"/>
+                                        </p:tgtEl>
+                                      </p:cBhvr>
+                                    </p:animEffect>
+                                  </p:childTnLst>
+                                </p:cTn>
+                              </p:par>
+                              <p:par>
+                                <p:cTn id="32" presetID="10" presetClass="entr" presetSubtype="0" fill="hold" grpId="0" nodeType="withEffect">
+                                  <p:stCondLst>
+                                    <p:cond delay="0"/>
+                                  </p:stCondLst>
+                                  <p:childTnLst>
+                                    <p:set>
+                                      <p:cBhvr>
+                                        <p:cTn id="33" dur="1" fill="hold">
+                                          <p:stCondLst>
+                                            <p:cond delay="0"/>
+                                          </p:stCondLst>
+                                        </p:cTn>
+                                        <p:tgtEl>
+                                          <p:spTgt spid="39"/>
+                                        </p:tgtEl>
+                                        <p:attrNameLst>
+                                          <p:attrName>style.visibility</p:attrName>
+                                        </p:attrNameLst>
+                                      </p:cBhvr>
+                                      <p:to>
+                                        <p:strVal val="visible"/>
+                                      </p:to>
+                                    </p:set>
+                                    <p:animEffect transition="in" filter="fade">
+                                      <p:cBhvr>
+                                        <p:cTn id="34" dur="450"/>
+                                        <p:tgtEl>
+                                          <p:spTgt spid="39"/>
+                                        </p:tgtEl>
+                                      </p:cBhvr>
+                                    </p:animEffect>
+                                  </p:childTnLst>
+                                </p:cTn>
+                              </p:par>
+                            </p:childTnLst>
+                          </p:cTn>
+                        </p:par>
+                      </p:childTnLst>
+                    </p:cTn>
+                  </p:par>
+                </p:childTnLst>
+              </p:cTn>
+              <p:prevCondLst>
+                <p:cond evt="onPrev" delay="0">
+                  <p:tgtEl>
+                    <p:sldTgt/>
+                  </p:tgtEl>
+                </p:cond>
+              </p:prevCondLst>
+              <p:nextCondLst>
+                <p:cond evt="onNext" delay="0">
+                  <p:tgtEl>
+                    <p:sldTgt/>
+                  </p:tgtEl>
+                </p:cond>
+              </p:nextCondLst>
+            </p:seq>
+          </p:childTnLst>
+        </p:cTn>
+      </p:par>
+    </p:tnLst>
+    <p:bldLst>
+      <p:bldP spid="30" grpId="0"/>
+      <p:bldP spid="31" grpId="0" animBg="1"/>
+      <p:bldP spid="32" grpId="0"/>
+      <p:bldP spid="34" grpId="0" animBg="1"/>
+      <p:bldP spid="36" grpId="0"/>
+      <p:bldP spid="38" grpId="0" animBg="1"/>
+      <p:bldP spid="39" grpId="0"/>
+    </p:bldLst>
+  </p:timing>
 </p:sld>
 </file>
 
@@ -11632,6 +12895,9 @@
   <p:clrMapOvr>
     <a:masterClrMapping/>
   </p:clrMapOvr>
+  <p:transition spd="fast">
+    <p:fade/>
+  </p:transition>
 </p:sld>
 </file>
 
@@ -11730,7 +12996,7 @@
         <p:spPr>
           <a:xfrm>
             <a:off x="320040" y="1162050"/>
-            <a:ext cx="5257800" cy="192000"/>
+            <a:ext cx="8382000" cy="192000"/>
           </a:xfrm>
           <a:prstGeom prst="rect">
             <a:avLst/>
@@ -11788,7 +13054,7 @@
         <p:spPr>
           <a:xfrm>
             <a:off x="411480" y="1405890"/>
-            <a:ext cx="5074800" cy="288000"/>
+            <a:ext cx="8199000" cy="288000"/>
           </a:xfrm>
           <a:prstGeom prst="roundRect">
             <a:avLst>
@@ -11840,7 +13106,7 @@
         <p:spPr>
           <a:xfrm>
             <a:off x="422910" y="1405890"/>
-            <a:ext cx="5052000" cy="288000"/>
+            <a:ext cx="8176200" cy="288000"/>
           </a:xfrm>
           <a:prstGeom prst="rect">
             <a:avLst/>
@@ -11898,7 +13164,7 @@
         <p:spPr>
           <a:xfrm>
             <a:off x="320040" y="1710690"/>
-            <a:ext cx="5257800" cy="192000"/>
+            <a:ext cx="8382000" cy="192000"/>
           </a:xfrm>
           <a:prstGeom prst="rect">
             <a:avLst/>
@@ -11956,7 +13222,7 @@
         <p:spPr>
           <a:xfrm>
             <a:off x="411480" y="1954530"/>
-            <a:ext cx="5074800" cy="288000"/>
+            <a:ext cx="8199000" cy="288000"/>
           </a:xfrm>
           <a:prstGeom prst="roundRect">
             <a:avLst>
@@ -12008,7 +13274,7 @@
         <p:spPr>
           <a:xfrm>
             <a:off x="422910" y="1954530"/>
-            <a:ext cx="5052000" cy="288000"/>
+            <a:ext cx="8176200" cy="288000"/>
           </a:xfrm>
           <a:prstGeom prst="rect">
             <a:avLst/>
@@ -12066,7 +13332,7 @@
         <p:spPr>
           <a:xfrm>
             <a:off x="320040" y="2259330"/>
-            <a:ext cx="5257800" cy="192000"/>
+            <a:ext cx="8382000" cy="192000"/>
           </a:xfrm>
           <a:prstGeom prst="rect">
             <a:avLst/>
@@ -12124,7 +13390,7 @@
         <p:spPr>
           <a:xfrm>
             <a:off x="411480" y="2503170"/>
-            <a:ext cx="5074800" cy="288000"/>
+            <a:ext cx="8199000" cy="288000"/>
           </a:xfrm>
           <a:prstGeom prst="roundRect">
             <a:avLst>
@@ -12176,7 +13442,7 @@
         <p:spPr>
           <a:xfrm>
             <a:off x="422910" y="2503170"/>
-            <a:ext cx="5052000" cy="288000"/>
+            <a:ext cx="8176200" cy="288000"/>
           </a:xfrm>
           <a:prstGeom prst="rect">
             <a:avLst/>
@@ -12234,7 +13500,7 @@
         <p:spPr>
           <a:xfrm>
             <a:off x="320040" y="2807970"/>
-            <a:ext cx="5257800" cy="192000"/>
+            <a:ext cx="8382000" cy="192000"/>
           </a:xfrm>
           <a:prstGeom prst="rect">
             <a:avLst/>
@@ -12292,7 +13558,7 @@
         <p:spPr>
           <a:xfrm>
             <a:off x="411480" y="3051810"/>
-            <a:ext cx="5074800" cy="288000"/>
+            <a:ext cx="8199000" cy="288000"/>
           </a:xfrm>
           <a:prstGeom prst="roundRect">
             <a:avLst>
@@ -12344,7 +13610,7 @@
         <p:spPr>
           <a:xfrm>
             <a:off x="422910" y="3051810"/>
-            <a:ext cx="5052000" cy="288000"/>
+            <a:ext cx="8176200" cy="288000"/>
           </a:xfrm>
           <a:prstGeom prst="rect">
             <a:avLst/>
@@ -12402,7 +13668,7 @@
         <p:spPr>
           <a:xfrm>
             <a:off x="320040" y="3356610"/>
-            <a:ext cx="5257800" cy="192000"/>
+            <a:ext cx="8382000" cy="192000"/>
           </a:xfrm>
           <a:prstGeom prst="rect">
             <a:avLst/>
@@ -12460,7 +13726,7 @@
         <p:spPr>
           <a:xfrm>
             <a:off x="411480" y="3600450"/>
-            <a:ext cx="5074800" cy="288000"/>
+            <a:ext cx="8199000" cy="288000"/>
           </a:xfrm>
           <a:prstGeom prst="roundRect">
             <a:avLst>
@@ -12512,7 +13778,7 @@
         <p:spPr>
           <a:xfrm>
             <a:off x="422910" y="3600450"/>
-            <a:ext cx="5052000" cy="288000"/>
+            <a:ext cx="8176200" cy="288000"/>
           </a:xfrm>
           <a:prstGeom prst="rect">
             <a:avLst/>
@@ -12570,7 +13836,7 @@
         <p:spPr>
           <a:xfrm>
             <a:off x="320040" y="3905250"/>
-            <a:ext cx="5257800" cy="192000"/>
+            <a:ext cx="8382000" cy="192000"/>
           </a:xfrm>
           <a:prstGeom prst="rect">
             <a:avLst/>
@@ -12628,7 +13894,7 @@
         <p:spPr>
           <a:xfrm>
             <a:off x="411480" y="4149090"/>
-            <a:ext cx="5074800" cy="288000"/>
+            <a:ext cx="8199000" cy="288000"/>
           </a:xfrm>
           <a:prstGeom prst="roundRect">
             <a:avLst>
@@ -12680,7 +13946,7 @@
         <p:spPr>
           <a:xfrm>
             <a:off x="422910" y="4149090"/>
-            <a:ext cx="5052000" cy="288000"/>
+            <a:ext cx="8176200" cy="288000"/>
           </a:xfrm>
           <a:prstGeom prst="rect">
             <a:avLst/>
@@ -12729,414 +13995,14 @@
           </a:p>
         </p:txBody>
       </p:sp>
-      <p:sp>
-        <p:nvSpPr>
-          <p:cNvPr id="99" name="TextBox 98"/>
-          <p:cNvSpPr txBox="1"/>
-          <p:nvPr/>
-        </p:nvSpPr>
-        <p:spPr>
-          <a:xfrm>
-            <a:off x="5829300" y="1193800"/>
-            <a:ext cx="3048000" cy="889000"/>
-          </a:xfrm>
-          <a:prstGeom prst="rect">
-            <a:avLst/>
-          </a:prstGeom>
-          <a:noFill/>
-        </p:spPr>
-        <p:txBody>
-          <a:bodyPr wrap="square" anchor="t" lIns="45720" rIns="45720">
-            <a:spAutoFit/>
-          </a:bodyPr>
-          <a:lstStyle/>
-          <a:p>
-            <a:pPr algn="l"/>
-            <a:r>
-              <a:rPr sz="5400" b="0">
-                <a:solidFill>
-                  <a:srgbClr val="0F1A2A"/>
-                </a:solidFill>
-                <a:latin typeface="Sora SemiBold"/>
-              </a:rPr>
-              <a:t>1 in 2</a:t>
-            </a:r>
-          </a:p>
-        </p:txBody>
-      </p:sp>
-      <p:sp>
-        <p:nvSpPr>
-          <p:cNvPr id="100" name="TextBox 99"/>
-          <p:cNvSpPr txBox="1"/>
-          <p:nvPr/>
-        </p:nvSpPr>
-        <p:spPr>
-          <a:xfrm>
-            <a:off x="5829300" y="2032000"/>
-            <a:ext cx="3048000" cy="762000"/>
-          </a:xfrm>
-          <a:prstGeom prst="rect">
-            <a:avLst/>
-          </a:prstGeom>
-          <a:noFill/>
-        </p:spPr>
-        <p:txBody>
-          <a:bodyPr wrap="square" anchor="t" lIns="45720" rIns="45720">
-            <a:spAutoFit/>
-          </a:bodyPr>
-          <a:lstStyle/>
-          <a:p>
-            <a:pPr algn="l"/>
-            <a:r>
-              <a:rPr sz="1250" b="0">
-                <a:solidFill>
-                  <a:srgbClr val="0F1A2A"/>
-                </a:solidFill>
-                <a:latin typeface="DM Sans"/>
-              </a:rPr>
-              <a:t>Americans say the hassle of switching puts them off changing carriers.</a:t>
-            </a:r>
-          </a:p>
-        </p:txBody>
-      </p:sp>
-      <p:sp>
-        <p:nvSpPr>
-          <p:cNvPr id="101" name="Rectangle 100"/>
-          <p:cNvSpPr/>
-          <p:nvPr/>
-        </p:nvSpPr>
-        <p:spPr>
-          <a:xfrm>
-            <a:off x="5880100" y="2921000"/>
-            <a:ext cx="2794000" cy="12700"/>
-          </a:xfrm>
-          <a:prstGeom prst="rect">
-            <a:avLst/>
-          </a:prstGeom>
-          <a:solidFill>
-            <a:srgbClr val="CBD1DA"/>
-          </a:solidFill>
-          <a:ln>
-            <a:noFill/>
-          </a:ln>
-          <a:effectLst/>
-        </p:spPr>
-        <p:style>
-          <a:lnRef idx="1">
-            <a:schemeClr val="accent1"/>
-          </a:lnRef>
-          <a:fillRef idx="3">
-            <a:schemeClr val="accent1"/>
-          </a:fillRef>
-          <a:effectRef idx="2">
-            <a:schemeClr val="accent1"/>
-          </a:effectRef>
-          <a:fontRef idx="minor">
-            <a:schemeClr val="lt1"/>
-          </a:fontRef>
-        </p:style>
-        <p:txBody>
-          <a:bodyPr rtlCol="0" anchor="ctr"/>
-          <a:lstStyle/>
-          <a:p>
-            <a:pPr algn="ctr"/>
-          </a:p>
-        </p:txBody>
-      </p:sp>
-      <p:sp>
-        <p:nvSpPr>
-          <p:cNvPr id="102" name="TextBox 101"/>
-          <p:cNvSpPr txBox="1"/>
-          <p:nvPr/>
-        </p:nvSpPr>
-        <p:spPr>
-          <a:xfrm>
-            <a:off x="5829300" y="3048000"/>
-            <a:ext cx="3048000" cy="508000"/>
-          </a:xfrm>
-          <a:prstGeom prst="rect">
-            <a:avLst/>
-          </a:prstGeom>
-          <a:noFill/>
-        </p:spPr>
-        <p:txBody>
-          <a:bodyPr wrap="square" anchor="t" lIns="45720" rIns="45720">
-            <a:spAutoFit/>
-          </a:bodyPr>
-          <a:lstStyle/>
-          <a:p>
-            <a:pPr algn="l"/>
-            <a:r>
-              <a:rPr sz="3000" b="0">
-                <a:solidFill>
-                  <a:srgbClr val="0F1A2A"/>
-                </a:solidFill>
-                <a:latin typeface="Sora SemiBold"/>
-              </a:rPr>
-              <a:t>18%</a:t>
-            </a:r>
-          </a:p>
-        </p:txBody>
-      </p:sp>
-      <p:sp>
-        <p:nvSpPr>
-          <p:cNvPr id="103" name="TextBox 102"/>
-          <p:cNvSpPr txBox="1"/>
-          <p:nvPr/>
-        </p:nvSpPr>
-        <p:spPr>
-          <a:xfrm>
-            <a:off x="5829300" y="3530600"/>
-            <a:ext cx="3048000" cy="635000"/>
-          </a:xfrm>
-          <a:prstGeom prst="rect">
-            <a:avLst/>
-          </a:prstGeom>
-          <a:noFill/>
-        </p:spPr>
-        <p:txBody>
-          <a:bodyPr wrap="square" anchor="t" lIns="45720" rIns="45720">
-            <a:spAutoFit/>
-          </a:bodyPr>
-          <a:lstStyle/>
-          <a:p>
-            <a:pPr algn="l"/>
-            <a:r>
-              <a:rPr sz="1100" b="0">
-                <a:solidFill>
-                  <a:srgbClr val="5B6575"/>
-                </a:solidFill>
-                <a:latin typeface="DM Sans"/>
-              </a:rPr>
-              <a:t>of US shoppers who quit a checkout did it because it was too long or complicated.</a:t>
-            </a:r>
-          </a:p>
-        </p:txBody>
-      </p:sp>
-      <p:sp>
-        <p:nvSpPr>
-          <p:cNvPr id="104" name="TextBox 103"/>
-          <p:cNvSpPr txBox="1"/>
-          <p:nvPr/>
-        </p:nvSpPr>
-        <p:spPr>
-          <a:xfrm>
-            <a:off x="5829300" y="4267200"/>
-            <a:ext cx="3048000" cy="381000"/>
-          </a:xfrm>
-          <a:prstGeom prst="rect">
-            <a:avLst/>
-          </a:prstGeom>
-          <a:noFill/>
-        </p:spPr>
-        <p:txBody>
-          <a:bodyPr wrap="square" anchor="t" lIns="45720" rIns="45720">
-            <a:spAutoFit/>
-          </a:bodyPr>
-          <a:lstStyle/>
-          <a:p>
-            <a:pPr algn="l"/>
-            <a:r>
-              <a:rPr sz="850" b="0">
-                <a:solidFill>
-                  <a:srgbClr val="8A94A3"/>
-                </a:solidFill>
-                <a:latin typeface="DM Sans"/>
-              </a:rPr>
-              <a:t>Sources: YouGov, Jan 2023 · Baymard Institute, 2025</a:t>
-            </a:r>
-          </a:p>
-        </p:txBody>
-      </p:sp>
-      <p:sp>
-        <p:nvSpPr>
-          <p:cNvPr id="105" name="Rounded Rectangle 104"/>
-          <p:cNvSpPr/>
-          <p:nvPr/>
-        </p:nvSpPr>
-        <p:spPr>
-          <a:xfrm>
-            <a:off x="5880100" y="2717800"/>
-            <a:ext cx="2667000" cy="88900"/>
-          </a:xfrm>
-          <a:prstGeom prst="roundRect">
-            <a:avLst>
-              <a:gd name="adj" fmla="val 50000"/>
-            </a:avLst>
-          </a:prstGeom>
-          <a:solidFill>
-            <a:srgbClr val="E9ECF1"/>
-          </a:solidFill>
-          <a:ln>
-            <a:noFill/>
-          </a:ln>
-          <a:effectLst/>
-        </p:spPr>
-        <p:style>
-          <a:lnRef idx="1">
-            <a:schemeClr val="accent1"/>
-          </a:lnRef>
-          <a:fillRef idx="3">
-            <a:schemeClr val="accent1"/>
-          </a:fillRef>
-          <a:effectRef idx="2">
-            <a:schemeClr val="accent1"/>
-          </a:effectRef>
-          <a:fontRef idx="minor">
-            <a:schemeClr val="lt1"/>
-          </a:fontRef>
-        </p:style>
-        <p:txBody>
-          <a:bodyPr rtlCol="0" anchor="ctr"/>
-          <a:lstStyle/>
-          <a:p>
-            <a:pPr algn="ctr"/>
-          </a:p>
-        </p:txBody>
-      </p:sp>
-      <p:sp>
-        <p:nvSpPr>
-          <p:cNvPr id="106" name="Rounded Rectangle 105"/>
-          <p:cNvSpPr/>
-          <p:nvPr/>
-        </p:nvSpPr>
-        <p:spPr>
-          <a:xfrm>
-            <a:off x="5880100" y="2717800"/>
-            <a:ext cx="1333500" cy="88900"/>
-          </a:xfrm>
-          <a:prstGeom prst="roundRect">
-            <a:avLst>
-              <a:gd name="adj" fmla="val 50000"/>
-            </a:avLst>
-          </a:prstGeom>
-          <a:solidFill>
-            <a:srgbClr val="22C985"/>
-          </a:solidFill>
-          <a:ln>
-            <a:noFill/>
-          </a:ln>
-          <a:effectLst/>
-        </p:spPr>
-        <p:style>
-          <a:lnRef idx="1">
-            <a:schemeClr val="accent1"/>
-          </a:lnRef>
-          <a:fillRef idx="3">
-            <a:schemeClr val="accent1"/>
-          </a:fillRef>
-          <a:effectRef idx="2">
-            <a:schemeClr val="accent1"/>
-          </a:effectRef>
-          <a:fontRef idx="minor">
-            <a:schemeClr val="lt1"/>
-          </a:fontRef>
-        </p:style>
-        <p:txBody>
-          <a:bodyPr rtlCol="0" anchor="ctr"/>
-          <a:lstStyle/>
-          <a:p>
-            <a:pPr algn="ctr"/>
-          </a:p>
-        </p:txBody>
-      </p:sp>
-      <p:sp>
-        <p:nvSpPr>
-          <p:cNvPr id="107" name="Rounded Rectangle 106"/>
-          <p:cNvSpPr/>
-          <p:nvPr/>
-        </p:nvSpPr>
-        <p:spPr>
-          <a:xfrm>
-            <a:off x="5880100" y="4038600"/>
-            <a:ext cx="2667000" cy="88900"/>
-          </a:xfrm>
-          <a:prstGeom prst="roundRect">
-            <a:avLst>
-              <a:gd name="adj" fmla="val 50000"/>
-            </a:avLst>
-          </a:prstGeom>
-          <a:solidFill>
-            <a:srgbClr val="E9ECF1"/>
-          </a:solidFill>
-          <a:ln>
-            <a:noFill/>
-          </a:ln>
-          <a:effectLst/>
-        </p:spPr>
-        <p:style>
-          <a:lnRef idx="1">
-            <a:schemeClr val="accent1"/>
-          </a:lnRef>
-          <a:fillRef idx="3">
-            <a:schemeClr val="accent1"/>
-          </a:fillRef>
-          <a:effectRef idx="2">
-            <a:schemeClr val="accent1"/>
-          </a:effectRef>
-          <a:fontRef idx="minor">
-            <a:schemeClr val="lt1"/>
-          </a:fontRef>
-        </p:style>
-        <p:txBody>
-          <a:bodyPr rtlCol="0" anchor="ctr"/>
-          <a:lstStyle/>
-          <a:p>
-            <a:pPr algn="ctr"/>
-          </a:p>
-        </p:txBody>
-      </p:sp>
-      <p:sp>
-        <p:nvSpPr>
-          <p:cNvPr id="108" name="Rounded Rectangle 107"/>
-          <p:cNvSpPr/>
-          <p:nvPr/>
-        </p:nvSpPr>
-        <p:spPr>
-          <a:xfrm>
-            <a:off x="5880100" y="4038600"/>
-            <a:ext cx="480059" cy="88900"/>
-          </a:xfrm>
-          <a:prstGeom prst="roundRect">
-            <a:avLst>
-              <a:gd name="adj" fmla="val 50000"/>
-            </a:avLst>
-          </a:prstGeom>
-          <a:solidFill>
-            <a:srgbClr val="22C985"/>
-          </a:solidFill>
-          <a:ln>
-            <a:noFill/>
-          </a:ln>
-          <a:effectLst/>
-        </p:spPr>
-        <p:style>
-          <a:lnRef idx="1">
-            <a:schemeClr val="accent1"/>
-          </a:lnRef>
-          <a:fillRef idx="3">
-            <a:schemeClr val="accent1"/>
-          </a:fillRef>
-          <a:effectRef idx="2">
-            <a:schemeClr val="accent1"/>
-          </a:effectRef>
-          <a:fontRef idx="minor">
-            <a:schemeClr val="lt1"/>
-          </a:fontRef>
-        </p:style>
-        <p:txBody>
-          <a:bodyPr rtlCol="0" anchor="ctr"/>
-          <a:lstStyle/>
-          <a:p>
-            <a:pPr algn="ctr"/>
-          </a:p>
-        </p:txBody>
-      </p:sp>
     </p:spTree>
   </p:cSld>
   <p:clrMapOvr>
     <a:masterClrMapping/>
   </p:clrMapOvr>
+  <p:transition spd="fast">
+    <p:fade/>
+  </p:transition>
 </p:sld>
 </file>
 
@@ -14417,6 +15283,634 @@
   <p:clrMapOvr>
     <a:masterClrMapping/>
   </p:clrMapOvr>
+  <p:transition spd="fast">
+    <p:fade/>
+  </p:transition>
+  <p:timing>
+    <p:tnLst>
+      <p:par>
+        <p:cTn id="1" dur="indefinite" restart="never" nodeType="tmRoot">
+          <p:childTnLst>
+            <p:seq concurrent="1" nextAc="seek">
+              <p:cTn id="2" dur="indefinite" nodeType="mainSeq">
+                <p:childTnLst>
+                  <p:par>
+                    <p:cTn id="3" fill="hold">
+                      <p:stCondLst>
+                        <p:cond delay="indefinite"/>
+                        <p:cond evt="onBegin" delay="0">
+                          <p:tn val="2"/>
+                        </p:cond>
+                      </p:stCondLst>
+                      <p:childTnLst>
+                        <p:par>
+                          <p:cTn id="4" fill="hold">
+                            <p:stCondLst>
+                              <p:cond delay="0"/>
+                            </p:stCondLst>
+                            <p:childTnLst>
+                              <p:par>
+                                <p:cTn id="5" presetID="22" presetClass="entr" presetSubtype="8" fill="hold" grpId="0" nodeType="afterEffect">
+                                  <p:stCondLst>
+                                    <p:cond delay="200"/>
+                                  </p:stCondLst>
+                                  <p:childTnLst>
+                                    <p:set>
+                                      <p:cBhvr>
+                                        <p:cTn id="6" dur="1" fill="hold">
+                                          <p:stCondLst>
+                                            <p:cond delay="0"/>
+                                          </p:stCondLst>
+                                        </p:cTn>
+                                        <p:tgtEl>
+                                          <p:spTgt spid="110"/>
+                                        </p:tgtEl>
+                                        <p:attrNameLst>
+                                          <p:attrName>style.visibility</p:attrName>
+                                        </p:attrNameLst>
+                                      </p:cBhvr>
+                                      <p:to>
+                                        <p:strVal val="visible"/>
+                                      </p:to>
+                                    </p:set>
+                                    <p:animEffect transition="in" filter="wipe(left)">
+                                      <p:cBhvr>
+                                        <p:cTn id="7" dur="450"/>
+                                        <p:tgtEl>
+                                          <p:spTgt spid="110"/>
+                                        </p:tgtEl>
+                                      </p:cBhvr>
+                                    </p:animEffect>
+                                  </p:childTnLst>
+                                </p:cTn>
+                              </p:par>
+                              <p:par>
+                                <p:cTn id="8" presetID="10" presetClass="entr" presetSubtype="0" fill="hold" grpId="0" nodeType="withEffect">
+                                  <p:stCondLst>
+                                    <p:cond delay="450"/>
+                                  </p:stCondLst>
+                                  <p:childTnLst>
+                                    <p:set>
+                                      <p:cBhvr>
+                                        <p:cTn id="9" dur="1" fill="hold">
+                                          <p:stCondLst>
+                                            <p:cond delay="0"/>
+                                          </p:stCondLst>
+                                        </p:cTn>
+                                        <p:tgtEl>
+                                          <p:spTgt spid="127"/>
+                                        </p:tgtEl>
+                                        <p:attrNameLst>
+                                          <p:attrName>style.visibility</p:attrName>
+                                        </p:attrNameLst>
+                                      </p:cBhvr>
+                                      <p:to>
+                                        <p:strVal val="visible"/>
+                                      </p:to>
+                                    </p:set>
+                                    <p:animEffect transition="in" filter="fade">
+                                      <p:cBhvr>
+                                        <p:cTn id="10" dur="450"/>
+                                        <p:tgtEl>
+                                          <p:spTgt spid="127"/>
+                                        </p:tgtEl>
+                                      </p:cBhvr>
+                                    </p:animEffect>
+                                  </p:childTnLst>
+                                </p:cTn>
+                              </p:par>
+                              <p:par>
+                                <p:cTn id="11" presetID="10" presetClass="entr" presetSubtype="0" fill="hold" grpId="0" nodeType="withEffect">
+                                  <p:stCondLst>
+                                    <p:cond delay="450"/>
+                                  </p:stCondLst>
+                                  <p:childTnLst>
+                                    <p:set>
+                                      <p:cBhvr>
+                                        <p:cTn id="12" dur="1" fill="hold">
+                                          <p:stCondLst>
+                                            <p:cond delay="0"/>
+                                          </p:stCondLst>
+                                        </p:cTn>
+                                        <p:tgtEl>
+                                          <p:spTgt spid="108"/>
+                                        </p:tgtEl>
+                                        <p:attrNameLst>
+                                          <p:attrName>style.visibility</p:attrName>
+                                        </p:attrNameLst>
+                                      </p:cBhvr>
+                                      <p:to>
+                                        <p:strVal val="visible"/>
+                                      </p:to>
+                                    </p:set>
+                                    <p:animEffect transition="in" filter="fade">
+                                      <p:cBhvr>
+                                        <p:cTn id="13" dur="450"/>
+                                        <p:tgtEl>
+                                          <p:spTgt spid="108"/>
+                                        </p:tgtEl>
+                                      </p:cBhvr>
+                                    </p:animEffect>
+                                  </p:childTnLst>
+                                </p:cTn>
+                              </p:par>
+                              <p:par>
+                                <p:cTn id="14" presetID="10" presetClass="entr" presetSubtype="0" fill="hold" grpId="0" nodeType="withEffect">
+                                  <p:stCondLst>
+                                    <p:cond delay="450"/>
+                                  </p:stCondLst>
+                                  <p:childTnLst>
+                                    <p:set>
+                                      <p:cBhvr>
+                                        <p:cTn id="15" dur="1" fill="hold">
+                                          <p:stCondLst>
+                                            <p:cond delay="0"/>
+                                          </p:stCondLst>
+                                        </p:cTn>
+                                        <p:tgtEl>
+                                          <p:spTgt spid="109"/>
+                                        </p:tgtEl>
+                                        <p:attrNameLst>
+                                          <p:attrName>style.visibility</p:attrName>
+                                        </p:attrNameLst>
+                                      </p:cBhvr>
+                                      <p:to>
+                                        <p:strVal val="visible"/>
+                                      </p:to>
+                                    </p:set>
+                                    <p:animEffect transition="in" filter="fade">
+                                      <p:cBhvr>
+                                        <p:cTn id="16" dur="450"/>
+                                        <p:tgtEl>
+                                          <p:spTgt spid="109"/>
+                                        </p:tgtEl>
+                                      </p:cBhvr>
+                                    </p:animEffect>
+                                  </p:childTnLst>
+                                </p:cTn>
+                              </p:par>
+                              <p:par>
+                                <p:cTn id="17" presetID="22" presetClass="entr" presetSubtype="8" fill="hold" grpId="0" nodeType="withEffect">
+                                  <p:stCondLst>
+                                    <p:cond delay="650"/>
+                                  </p:stCondLst>
+                                  <p:childTnLst>
+                                    <p:set>
+                                      <p:cBhvr>
+                                        <p:cTn id="18" dur="1" fill="hold">
+                                          <p:stCondLst>
+                                            <p:cond delay="0"/>
+                                          </p:stCondLst>
+                                        </p:cTn>
+                                        <p:tgtEl>
+                                          <p:spTgt spid="115"/>
+                                        </p:tgtEl>
+                                        <p:attrNameLst>
+                                          <p:attrName>style.visibility</p:attrName>
+                                        </p:attrNameLst>
+                                      </p:cBhvr>
+                                      <p:to>
+                                        <p:strVal val="visible"/>
+                                      </p:to>
+                                    </p:set>
+                                    <p:animEffect transition="in" filter="wipe(left)">
+                                      <p:cBhvr>
+                                        <p:cTn id="19" dur="450"/>
+                                        <p:tgtEl>
+                                          <p:spTgt spid="115"/>
+                                        </p:tgtEl>
+                                      </p:cBhvr>
+                                    </p:animEffect>
+                                  </p:childTnLst>
+                                </p:cTn>
+                              </p:par>
+                              <p:par>
+                                <p:cTn id="20" presetID="10" presetClass="entr" presetSubtype="0" fill="hold" grpId="0" nodeType="withEffect">
+                                  <p:stCondLst>
+                                    <p:cond delay="900"/>
+                                  </p:stCondLst>
+                                  <p:childTnLst>
+                                    <p:set>
+                                      <p:cBhvr>
+                                        <p:cTn id="21" dur="1" fill="hold">
+                                          <p:stCondLst>
+                                            <p:cond delay="0"/>
+                                          </p:stCondLst>
+                                        </p:cTn>
+                                        <p:tgtEl>
+                                          <p:spTgt spid="128"/>
+                                        </p:tgtEl>
+                                        <p:attrNameLst>
+                                          <p:attrName>style.visibility</p:attrName>
+                                        </p:attrNameLst>
+                                      </p:cBhvr>
+                                      <p:to>
+                                        <p:strVal val="visible"/>
+                                      </p:to>
+                                    </p:set>
+                                    <p:animEffect transition="in" filter="fade">
+                                      <p:cBhvr>
+                                        <p:cTn id="22" dur="450"/>
+                                        <p:tgtEl>
+                                          <p:spTgt spid="128"/>
+                                        </p:tgtEl>
+                                      </p:cBhvr>
+                                    </p:animEffect>
+                                  </p:childTnLst>
+                                </p:cTn>
+                              </p:par>
+                              <p:par>
+                                <p:cTn id="23" presetID="10" presetClass="entr" presetSubtype="0" fill="hold" grpId="0" nodeType="withEffect">
+                                  <p:stCondLst>
+                                    <p:cond delay="900"/>
+                                  </p:stCondLst>
+                                  <p:childTnLst>
+                                    <p:set>
+                                      <p:cBhvr>
+                                        <p:cTn id="24" dur="1" fill="hold">
+                                          <p:stCondLst>
+                                            <p:cond delay="0"/>
+                                          </p:stCondLst>
+                                        </p:cTn>
+                                        <p:tgtEl>
+                                          <p:spTgt spid="113"/>
+                                        </p:tgtEl>
+                                        <p:attrNameLst>
+                                          <p:attrName>style.visibility</p:attrName>
+                                        </p:attrNameLst>
+                                      </p:cBhvr>
+                                      <p:to>
+                                        <p:strVal val="visible"/>
+                                      </p:to>
+                                    </p:set>
+                                    <p:animEffect transition="in" filter="fade">
+                                      <p:cBhvr>
+                                        <p:cTn id="25" dur="450"/>
+                                        <p:tgtEl>
+                                          <p:spTgt spid="113"/>
+                                        </p:tgtEl>
+                                      </p:cBhvr>
+                                    </p:animEffect>
+                                  </p:childTnLst>
+                                </p:cTn>
+                              </p:par>
+                              <p:par>
+                                <p:cTn id="26" presetID="10" presetClass="entr" presetSubtype="0" fill="hold" grpId="0" nodeType="withEffect">
+                                  <p:stCondLst>
+                                    <p:cond delay="900"/>
+                                  </p:stCondLst>
+                                  <p:childTnLst>
+                                    <p:set>
+                                      <p:cBhvr>
+                                        <p:cTn id="27" dur="1" fill="hold">
+                                          <p:stCondLst>
+                                            <p:cond delay="0"/>
+                                          </p:stCondLst>
+                                        </p:cTn>
+                                        <p:tgtEl>
+                                          <p:spTgt spid="114"/>
+                                        </p:tgtEl>
+                                        <p:attrNameLst>
+                                          <p:attrName>style.visibility</p:attrName>
+                                        </p:attrNameLst>
+                                      </p:cBhvr>
+                                      <p:to>
+                                        <p:strVal val="visible"/>
+                                      </p:to>
+                                    </p:set>
+                                    <p:animEffect transition="in" filter="fade">
+                                      <p:cBhvr>
+                                        <p:cTn id="28" dur="450"/>
+                                        <p:tgtEl>
+                                          <p:spTgt spid="114"/>
+                                        </p:tgtEl>
+                                      </p:cBhvr>
+                                    </p:animEffect>
+                                  </p:childTnLst>
+                                </p:cTn>
+                              </p:par>
+                              <p:par>
+                                <p:cTn id="29" presetID="22" presetClass="entr" presetSubtype="8" fill="hold" grpId="0" nodeType="withEffect">
+                                  <p:stCondLst>
+                                    <p:cond delay="1100"/>
+                                  </p:stCondLst>
+                                  <p:childTnLst>
+                                    <p:set>
+                                      <p:cBhvr>
+                                        <p:cTn id="30" dur="1" fill="hold">
+                                          <p:stCondLst>
+                                            <p:cond delay="0"/>
+                                          </p:stCondLst>
+                                        </p:cTn>
+                                        <p:tgtEl>
+                                          <p:spTgt spid="120"/>
+                                        </p:tgtEl>
+                                        <p:attrNameLst>
+                                          <p:attrName>style.visibility</p:attrName>
+                                        </p:attrNameLst>
+                                      </p:cBhvr>
+                                      <p:to>
+                                        <p:strVal val="visible"/>
+                                      </p:to>
+                                    </p:set>
+                                    <p:animEffect transition="in" filter="wipe(left)">
+                                      <p:cBhvr>
+                                        <p:cTn id="31" dur="450"/>
+                                        <p:tgtEl>
+                                          <p:spTgt spid="120"/>
+                                        </p:tgtEl>
+                                      </p:cBhvr>
+                                    </p:animEffect>
+                                  </p:childTnLst>
+                                </p:cTn>
+                              </p:par>
+                              <p:par>
+                                <p:cTn id="32" presetID="10" presetClass="entr" presetSubtype="0" fill="hold" grpId="0" nodeType="withEffect">
+                                  <p:stCondLst>
+                                    <p:cond delay="1350"/>
+                                  </p:stCondLst>
+                                  <p:childTnLst>
+                                    <p:set>
+                                      <p:cBhvr>
+                                        <p:cTn id="33" dur="1" fill="hold">
+                                          <p:stCondLst>
+                                            <p:cond delay="0"/>
+                                          </p:stCondLst>
+                                        </p:cTn>
+                                        <p:tgtEl>
+                                          <p:spTgt spid="129"/>
+                                        </p:tgtEl>
+                                        <p:attrNameLst>
+                                          <p:attrName>style.visibility</p:attrName>
+                                        </p:attrNameLst>
+                                      </p:cBhvr>
+                                      <p:to>
+                                        <p:strVal val="visible"/>
+                                      </p:to>
+                                    </p:set>
+                                    <p:animEffect transition="in" filter="fade">
+                                      <p:cBhvr>
+                                        <p:cTn id="34" dur="450"/>
+                                        <p:tgtEl>
+                                          <p:spTgt spid="129"/>
+                                        </p:tgtEl>
+                                      </p:cBhvr>
+                                    </p:animEffect>
+                                  </p:childTnLst>
+                                </p:cTn>
+                              </p:par>
+                              <p:par>
+                                <p:cTn id="35" presetID="10" presetClass="entr" presetSubtype="0" fill="hold" grpId="0" nodeType="withEffect">
+                                  <p:stCondLst>
+                                    <p:cond delay="1350"/>
+                                  </p:stCondLst>
+                                  <p:childTnLst>
+                                    <p:set>
+                                      <p:cBhvr>
+                                        <p:cTn id="36" dur="1" fill="hold">
+                                          <p:stCondLst>
+                                            <p:cond delay="0"/>
+                                          </p:stCondLst>
+                                        </p:cTn>
+                                        <p:tgtEl>
+                                          <p:spTgt spid="118"/>
+                                        </p:tgtEl>
+                                        <p:attrNameLst>
+                                          <p:attrName>style.visibility</p:attrName>
+                                        </p:attrNameLst>
+                                      </p:cBhvr>
+                                      <p:to>
+                                        <p:strVal val="visible"/>
+                                      </p:to>
+                                    </p:set>
+                                    <p:animEffect transition="in" filter="fade">
+                                      <p:cBhvr>
+                                        <p:cTn id="37" dur="450"/>
+                                        <p:tgtEl>
+                                          <p:spTgt spid="118"/>
+                                        </p:tgtEl>
+                                      </p:cBhvr>
+                                    </p:animEffect>
+                                  </p:childTnLst>
+                                </p:cTn>
+                              </p:par>
+                              <p:par>
+                                <p:cTn id="38" presetID="10" presetClass="entr" presetSubtype="0" fill="hold" grpId="0" nodeType="withEffect">
+                                  <p:stCondLst>
+                                    <p:cond delay="1350"/>
+                                  </p:stCondLst>
+                                  <p:childTnLst>
+                                    <p:set>
+                                      <p:cBhvr>
+                                        <p:cTn id="39" dur="1" fill="hold">
+                                          <p:stCondLst>
+                                            <p:cond delay="0"/>
+                                          </p:stCondLst>
+                                        </p:cTn>
+                                        <p:tgtEl>
+                                          <p:spTgt spid="119"/>
+                                        </p:tgtEl>
+                                        <p:attrNameLst>
+                                          <p:attrName>style.visibility</p:attrName>
+                                        </p:attrNameLst>
+                                      </p:cBhvr>
+                                      <p:to>
+                                        <p:strVal val="visible"/>
+                                      </p:to>
+                                    </p:set>
+                                    <p:animEffect transition="in" filter="fade">
+                                      <p:cBhvr>
+                                        <p:cTn id="40" dur="450"/>
+                                        <p:tgtEl>
+                                          <p:spTgt spid="119"/>
+                                        </p:tgtEl>
+                                      </p:cBhvr>
+                                    </p:animEffect>
+                                  </p:childTnLst>
+                                </p:cTn>
+                              </p:par>
+                              <p:par>
+                                <p:cTn id="41" presetID="22" presetClass="entr" presetSubtype="8" fill="hold" grpId="0" nodeType="withEffect">
+                                  <p:stCondLst>
+                                    <p:cond delay="1550"/>
+                                  </p:stCondLst>
+                                  <p:childTnLst>
+                                    <p:set>
+                                      <p:cBhvr>
+                                        <p:cTn id="42" dur="1" fill="hold">
+                                          <p:stCondLst>
+                                            <p:cond delay="0"/>
+                                          </p:stCondLst>
+                                        </p:cTn>
+                                        <p:tgtEl>
+                                          <p:spTgt spid="125"/>
+                                        </p:tgtEl>
+                                        <p:attrNameLst>
+                                          <p:attrName>style.visibility</p:attrName>
+                                        </p:attrNameLst>
+                                      </p:cBhvr>
+                                      <p:to>
+                                        <p:strVal val="visible"/>
+                                      </p:to>
+                                    </p:set>
+                                    <p:animEffect transition="in" filter="wipe(left)">
+                                      <p:cBhvr>
+                                        <p:cTn id="43" dur="450"/>
+                                        <p:tgtEl>
+                                          <p:spTgt spid="125"/>
+                                        </p:tgtEl>
+                                      </p:cBhvr>
+                                    </p:animEffect>
+                                  </p:childTnLst>
+                                </p:cTn>
+                              </p:par>
+                              <p:par>
+                                <p:cTn id="44" presetID="10" presetClass="entr" presetSubtype="0" fill="hold" grpId="0" nodeType="withEffect">
+                                  <p:stCondLst>
+                                    <p:cond delay="1800"/>
+                                  </p:stCondLst>
+                                  <p:childTnLst>
+                                    <p:set>
+                                      <p:cBhvr>
+                                        <p:cTn id="45" dur="1" fill="hold">
+                                          <p:stCondLst>
+                                            <p:cond delay="0"/>
+                                          </p:stCondLst>
+                                        </p:cTn>
+                                        <p:tgtEl>
+                                          <p:spTgt spid="130"/>
+                                        </p:tgtEl>
+                                        <p:attrNameLst>
+                                          <p:attrName>style.visibility</p:attrName>
+                                        </p:attrNameLst>
+                                      </p:cBhvr>
+                                      <p:to>
+                                        <p:strVal val="visible"/>
+                                      </p:to>
+                                    </p:set>
+                                    <p:animEffect transition="in" filter="fade">
+                                      <p:cBhvr>
+                                        <p:cTn id="46" dur="450"/>
+                                        <p:tgtEl>
+                                          <p:spTgt spid="130"/>
+                                        </p:tgtEl>
+                                      </p:cBhvr>
+                                    </p:animEffect>
+                                  </p:childTnLst>
+                                </p:cTn>
+                              </p:par>
+                              <p:par>
+                                <p:cTn id="47" presetID="10" presetClass="entr" presetSubtype="0" fill="hold" grpId="0" nodeType="withEffect">
+                                  <p:stCondLst>
+                                    <p:cond delay="1800"/>
+                                  </p:stCondLst>
+                                  <p:childTnLst>
+                                    <p:set>
+                                      <p:cBhvr>
+                                        <p:cTn id="48" dur="1" fill="hold">
+                                          <p:stCondLst>
+                                            <p:cond delay="0"/>
+                                          </p:stCondLst>
+                                        </p:cTn>
+                                        <p:tgtEl>
+                                          <p:spTgt spid="123"/>
+                                        </p:tgtEl>
+                                        <p:attrNameLst>
+                                          <p:attrName>style.visibility</p:attrName>
+                                        </p:attrNameLst>
+                                      </p:cBhvr>
+                                      <p:to>
+                                        <p:strVal val="visible"/>
+                                      </p:to>
+                                    </p:set>
+                                    <p:animEffect transition="in" filter="fade">
+                                      <p:cBhvr>
+                                        <p:cTn id="49" dur="450"/>
+                                        <p:tgtEl>
+                                          <p:spTgt spid="123"/>
+                                        </p:tgtEl>
+                                      </p:cBhvr>
+                                    </p:animEffect>
+                                  </p:childTnLst>
+                                </p:cTn>
+                              </p:par>
+                              <p:par>
+                                <p:cTn id="50" presetID="10" presetClass="entr" presetSubtype="0" fill="hold" grpId="0" nodeType="withEffect">
+                                  <p:stCondLst>
+                                    <p:cond delay="1800"/>
+                                  </p:stCondLst>
+                                  <p:childTnLst>
+                                    <p:set>
+                                      <p:cBhvr>
+                                        <p:cTn id="51" dur="1" fill="hold">
+                                          <p:stCondLst>
+                                            <p:cond delay="0"/>
+                                          </p:stCondLst>
+                                        </p:cTn>
+                                        <p:tgtEl>
+                                          <p:spTgt spid="124"/>
+                                        </p:tgtEl>
+                                        <p:attrNameLst>
+                                          <p:attrName>style.visibility</p:attrName>
+                                        </p:attrNameLst>
+                                      </p:cBhvr>
+                                      <p:to>
+                                        <p:strVal val="visible"/>
+                                      </p:to>
+                                    </p:set>
+                                    <p:animEffect transition="in" filter="fade">
+                                      <p:cBhvr>
+                                        <p:cTn id="52" dur="450"/>
+                                        <p:tgtEl>
+                                          <p:spTgt spid="124"/>
+                                        </p:tgtEl>
+                                      </p:cBhvr>
+                                    </p:animEffect>
+                                  </p:childTnLst>
+                                </p:cTn>
+                              </p:par>
+                            </p:childTnLst>
+                          </p:cTn>
+                        </p:par>
+                      </p:childTnLst>
+                    </p:cTn>
+                  </p:par>
+                </p:childTnLst>
+              </p:cTn>
+              <p:prevCondLst>
+                <p:cond evt="onPrev" delay="0">
+                  <p:tgtEl>
+                    <p:sldTgt/>
+                  </p:tgtEl>
+                </p:cond>
+              </p:prevCondLst>
+              <p:nextCondLst>
+                <p:cond evt="onNext" delay="0">
+                  <p:tgtEl>
+                    <p:sldTgt/>
+                  </p:tgtEl>
+                </p:cond>
+              </p:nextCondLst>
+            </p:seq>
+          </p:childTnLst>
+        </p:cTn>
+      </p:par>
+    </p:tnLst>
+    <p:bldLst>
+      <p:bldP spid="127" grpId="0" animBg="1"/>
+      <p:bldP spid="108" grpId="0" animBg="1"/>
+      <p:bldP spid="109" grpId="0"/>
+      <p:bldP spid="128" grpId="0" animBg="1"/>
+      <p:bldP spid="113" grpId="0" animBg="1"/>
+      <p:bldP spid="114" grpId="0"/>
+      <p:bldP spid="129" grpId="0" animBg="1"/>
+      <p:bldP spid="118" grpId="0" animBg="1"/>
+      <p:bldP spid="119" grpId="0"/>
+      <p:bldP spid="130" grpId="0" animBg="1"/>
+      <p:bldP spid="123" grpId="0" animBg="1"/>
+      <p:bldP spid="124" grpId="0"/>
+    </p:bldLst>
+  </p:timing>
 </p:sld>
 </file>
 
@@ -16041,6 +17535,9 @@
   <p:clrMapOvr>
     <a:masterClrMapping/>
   </p:clrMapOvr>
+  <p:transition spd="fast">
+    <p:fade/>
+  </p:transition>
 </p:sld>
 </file>
 
@@ -17005,558 +18502,9 @@
   <p:clrMapOvr>
     <a:masterClrMapping/>
   </p:clrMapOvr>
-</p:sld>
-</file>
-
-<file path=ppt/slides/slide7.xml><?xml version="1.0" encoding="utf-8"?>
-<p:sld xmlns:a="http://schemas.openxmlformats.org/drawingml/2006/main" xmlns:r="http://schemas.openxmlformats.org/officeDocument/2006/relationships" xmlns:mc="http://schemas.openxmlformats.org/markup-compatibility/2006" xmlns:mv="urn:schemas-microsoft-com:mac:vml" xmlns:p="http://schemas.openxmlformats.org/presentationml/2006/main" xmlns:c="http://schemas.openxmlformats.org/drawingml/2006/chart" xmlns:dgm="http://schemas.openxmlformats.org/drawingml/2006/diagram" xmlns:o="urn:schemas-microsoft-com:office:office" xmlns:v="urn:schemas-microsoft-com:vml" xmlns:pvml="urn:schemas-microsoft-com:office:powerpoint" xmlns:com="http://schemas.openxmlformats.org/drawingml/2006/compatibility" xmlns:p14="http://schemas.microsoft.com/office/powerpoint/2010/main" xmlns:p15="http://schemas.microsoft.com/office/powerpoint/2012/main" xmlns:ahyp="http://schemas.microsoft.com/office/drawing/2018/hyperlinkcolor">
-  <p:cSld>
-    <p:bg>
-      <p:bgPr>
-        <a:solidFill>
-          <a:srgbClr val="0F1A2A"/>
-        </a:solidFill>
-      </p:bgPr>
-    </p:bg>
-    <p:spTree>
-      <p:nvGrpSpPr>
-        <p:cNvPr id="186" name="Shape 186"/>
-        <p:cNvGrpSpPr/>
-        <p:nvPr/>
-      </p:nvGrpSpPr>
-      <p:grpSpPr>
-        <a:xfrm>
-          <a:off x="0" y="0"/>
-          <a:ext cx="0" cy="0"/>
-          <a:chOff x="0" y="0"/>
-          <a:chExt cx="0" cy="0"/>
-        </a:xfrm>
-      </p:grpSpPr>
-      <p:sp>
-        <p:nvSpPr>
-          <p:cNvPr id="187" name="Google Shape;187;p19"/>
-          <p:cNvSpPr txBox="1"/>
-          <p:nvPr/>
-        </p:nvSpPr>
-        <p:spPr>
-          <a:xfrm>
-            <a:off x="320040" y="617220"/>
-            <a:ext cx="7041000" cy="1371600"/>
-          </a:xfrm>
-          <a:prstGeom prst="rect">
-            <a:avLst/>
-          </a:prstGeom>
-          <a:noFill/>
-          <a:ln>
-            <a:noFill/>
-          </a:ln>
-        </p:spPr>
-        <p:txBody>
-          <a:bodyPr anchorCtr="0" anchor="t" bIns="91425" lIns="91425" spcFirstLastPara="1" rIns="91425" wrap="square" tIns="91425">
-            <a:noAutofit/>
-          </a:bodyPr>
-          <a:lstStyle/>
-          <a:p>
-            <a:pPr indent="0" lvl="0" marL="0" rtl="0" algn="l">
-              <a:spcBef>
-                <a:spcPts val="0"/>
-              </a:spcBef>
-              <a:spcAft>
-                <a:spcPts val="0"/>
-              </a:spcAft>
-              <a:buNone/>
-            </a:pPr>
-            <a:r>
-              <a:rPr lang="en" sz="5400" b="0">
-                <a:solidFill>
-                  <a:srgbClr val="FFFFFF"/>
-                </a:solidFill>
-                <a:latin typeface="Sora SemiBold"/>
-                <a:ea typeface="Sora SemiBold"/>
-                <a:cs typeface="Sora SemiBold"/>
-                <a:sym typeface="Sora SemiBold"/>
-              </a:rPr>
-              <a:t>Which was faster?</a:t>
-            </a:r>
-            <a:endParaRPr sz="8250" b="0">
-              <a:solidFill>
-                <a:srgbClr val="FFFFFF"/>
-              </a:solidFill>
-              <a:latin typeface="Sora SemiBold"/>
-              <a:ea typeface="Sora SemiBold"/>
-              <a:cs typeface="Sora SemiBold"/>
-              <a:sym typeface="Sora SemiBold"/>
-            </a:endParaRPr>
-          </a:p>
-        </p:txBody>
-      </p:sp>
-      <p:sp>
-        <p:nvSpPr>
-          <p:cNvPr id="188" name="Google Shape;188;p19"/>
-          <p:cNvSpPr txBox="1"/>
-          <p:nvPr/>
-        </p:nvSpPr>
-        <p:spPr>
-          <a:xfrm>
-            <a:off x="320040" y="2159000"/>
-            <a:ext cx="8412600" cy="274200"/>
-          </a:xfrm>
-          <a:prstGeom prst="rect">
-            <a:avLst/>
-          </a:prstGeom>
-          <a:noFill/>
-          <a:ln>
-            <a:noFill/>
-          </a:ln>
-        </p:spPr>
-        <p:txBody>
-          <a:bodyPr anchorCtr="0" anchor="t" bIns="91425" lIns="91425" spcFirstLastPara="1" rIns="91425" wrap="square" tIns="91425">
-            <a:noAutofit/>
-          </a:bodyPr>
-          <a:lstStyle/>
-          <a:p>
-            <a:pPr indent="0" lvl="0" marL="0" rtl="0" algn="l">
-              <a:spcBef>
-                <a:spcPts val="0"/>
-              </a:spcBef>
-              <a:spcAft>
-                <a:spcPts val="0"/>
-              </a:spcAft>
-              <a:buNone/>
-            </a:pPr>
-            <a:r>
-              <a:rPr lang="en" sz="1400" b="0">
-                <a:solidFill>
-                  <a:srgbClr val="CBD1DA"/>
-                </a:solidFill>
-                <a:latin typeface="DM Sans"/>
-                <a:ea typeface="DM Sans"/>
-                <a:cs typeface="DM Sans"/>
-                <a:sym typeface="DM Sans"/>
-              </a:rPr>
-              <a:t>Same T-Mobile switch form. Our times on the replica:</a:t>
-            </a:r>
-            <a:endParaRPr sz="1050" b="0">
-              <a:solidFill>
-                <a:srgbClr val="CBD1DA"/>
-              </a:solidFill>
-              <a:latin typeface="DM Sans"/>
-              <a:ea typeface="DM Sans"/>
-              <a:cs typeface="DM Sans"/>
-              <a:sym typeface="DM Sans"/>
-            </a:endParaRPr>
-          </a:p>
-        </p:txBody>
-      </p:sp>
-      <p:sp>
-        <p:nvSpPr>
-          <p:cNvPr id="189" name="Google Shape;189;p19"/>
-          <p:cNvSpPr txBox="1"/>
-          <p:nvPr/>
-        </p:nvSpPr>
-        <p:spPr>
-          <a:xfrm>
-            <a:off x="320040" y="3098800"/>
-            <a:ext cx="4160400" cy="205800"/>
-          </a:xfrm>
-          <a:prstGeom prst="rect">
-            <a:avLst/>
-          </a:prstGeom>
-          <a:noFill/>
-          <a:ln>
-            <a:noFill/>
-          </a:ln>
-        </p:spPr>
-        <p:txBody>
-          <a:bodyPr anchorCtr="0" anchor="t" bIns="91425" lIns="91425" spcFirstLastPara="1" rIns="91425" wrap="square" tIns="91425">
-            <a:noAutofit/>
-          </a:bodyPr>
-          <a:lstStyle/>
-          <a:p>
-            <a:pPr indent="0" lvl="0" marL="0" rtl="0" algn="l">
-              <a:spcBef>
-                <a:spcPts val="0"/>
-              </a:spcBef>
-              <a:spcAft>
-                <a:spcPts val="0"/>
-              </a:spcAft>
-              <a:buNone/>
-            </a:pPr>
-            <a:r>
-              <a:rPr b="0" lang="en" sz="1200">
-                <a:solidFill>
-                  <a:srgbClr val="CBD1DA"/>
-                </a:solidFill>
-                <a:latin typeface="DM Sans Medium"/>
-                <a:ea typeface="DM Sans Medium"/>
-                <a:cs typeface="DM Sans Medium"/>
-                <a:sym typeface="DM Sans Medium"/>
-              </a:rPr>
-              <a:t>A · By hand</a:t>
-            </a:r>
-            <a:endParaRPr b="0" sz="900">
-              <a:solidFill>
-                <a:srgbClr val="CBD1DA"/>
-              </a:solidFill>
-              <a:latin typeface="DM Sans Medium"/>
-              <a:ea typeface="DM Sans Medium"/>
-              <a:cs typeface="DM Sans Medium"/>
-              <a:sym typeface="DM Sans Medium"/>
-            </a:endParaRPr>
-          </a:p>
-        </p:txBody>
-      </p:sp>
-      <p:sp>
-        <p:nvSpPr>
-          <p:cNvPr id="190" name="Google Shape;190;p19"/>
-          <p:cNvSpPr/>
-          <p:nvPr/>
-        </p:nvSpPr>
-        <p:spPr>
-          <a:xfrm>
-            <a:off x="411480" y="3394710"/>
-            <a:ext cx="3977700" cy="822900"/>
-          </a:xfrm>
-          <a:prstGeom prst="roundRect">
-            <a:avLst>
-              <a:gd fmla="val 16667" name="adj"/>
-            </a:avLst>
-          </a:prstGeom>
-          <a:solidFill>
-            <a:srgbClr val="0F1A2A"/>
-          </a:solidFill>
-          <a:ln cap="flat" cmpd="sng" w="12700">
-            <a:solidFill>
-              <a:srgbClr val="8A94A3"/>
-            </a:solidFill>
-            <a:prstDash val="solid"/>
-            <a:round/>
-            <a:headEnd len="sm" w="sm" type="none"/>
-            <a:tailEnd len="sm" w="sm" type="none"/>
-          </a:ln>
-        </p:spPr>
-        <p:txBody>
-          <a:bodyPr anchorCtr="0" anchor="ctr" bIns="91425" lIns="91425" spcFirstLastPara="1" rIns="91425" wrap="square" tIns="91425">
-            <a:noAutofit/>
-          </a:bodyPr>
-          <a:lstStyle/>
-          <a:p>
-            <a:pPr indent="0" lvl="0" marL="0" rtl="0" algn="ctr">
-              <a:spcBef>
-                <a:spcPts val="0"/>
-              </a:spcBef>
-              <a:spcAft>
-                <a:spcPts val="0"/>
-              </a:spcAft>
-              <a:buNone/>
-            </a:pPr>
-            <a:r>
-              <a:t/>
-            </a:r>
-            <a:endParaRPr/>
-          </a:p>
-        </p:txBody>
-      </p:sp>
-      <p:sp>
-        <p:nvSpPr>
-          <p:cNvPr id="191" name="Google Shape;191;p19"/>
-          <p:cNvSpPr txBox="1"/>
-          <p:nvPr/>
-        </p:nvSpPr>
-        <p:spPr>
-          <a:xfrm>
-            <a:off x="320040" y="3394710"/>
-            <a:ext cx="4160400" cy="822900"/>
-          </a:xfrm>
-          <a:prstGeom prst="rect">
-            <a:avLst/>
-          </a:prstGeom>
-          <a:noFill/>
-          <a:ln>
-            <a:noFill/>
-          </a:ln>
-        </p:spPr>
-        <p:txBody>
-          <a:bodyPr anchorCtr="0" anchor="ctr" bIns="91425" lIns="91425" spcFirstLastPara="1" rIns="91425" wrap="square" tIns="91425">
-            <a:noAutofit/>
-          </a:bodyPr>
-          <a:lstStyle/>
-          <a:p>
-            <a:pPr indent="0" lvl="0" marL="0" rtl="0" algn="ctr">
-              <a:spcBef>
-                <a:spcPts val="0"/>
-              </a:spcBef>
-              <a:spcAft>
-                <a:spcPts val="0"/>
-              </a:spcAft>
-              <a:buNone/>
-            </a:pPr>
-            <a:r>
-              <a:rPr lang="en" sz="3300" b="0">
-                <a:solidFill>
-                  <a:srgbClr val="FFFFFF"/>
-                </a:solidFill>
-                <a:latin typeface="Sora SemiBold"/>
-                <a:ea typeface="Sora SemiBold"/>
-                <a:cs typeface="Sora SemiBold"/>
-                <a:sym typeface="Sora SemiBold"/>
-              </a:rPr>
-              <a:t>[m:ss]</a:t>
-            </a:r>
-            <a:endParaRPr sz="3300" b="0">
-              <a:solidFill>
-                <a:srgbClr val="FFFFFF"/>
-              </a:solidFill>
-              <a:latin typeface="Sora SemiBold"/>
-              <a:ea typeface="Sora SemiBold"/>
-              <a:cs typeface="Sora SemiBold"/>
-              <a:sym typeface="Sora SemiBold"/>
-            </a:endParaRPr>
-          </a:p>
-        </p:txBody>
-      </p:sp>
-      <p:sp>
-        <p:nvSpPr>
-          <p:cNvPr id="192" name="Google Shape;192;p19"/>
-          <p:cNvSpPr txBox="1"/>
-          <p:nvPr/>
-        </p:nvSpPr>
-        <p:spPr>
-          <a:xfrm>
-            <a:off x="4640580" y="3098800"/>
-            <a:ext cx="4160400" cy="205800"/>
-          </a:xfrm>
-          <a:prstGeom prst="rect">
-            <a:avLst/>
-          </a:prstGeom>
-          <a:noFill/>
-          <a:ln>
-            <a:noFill/>
-          </a:ln>
-        </p:spPr>
-        <p:txBody>
-          <a:bodyPr anchorCtr="0" anchor="t" bIns="91425" lIns="91425" spcFirstLastPara="1" rIns="91425" wrap="square" tIns="91425">
-            <a:noAutofit/>
-          </a:bodyPr>
-          <a:lstStyle/>
-          <a:p>
-            <a:pPr indent="0" lvl="0" marL="0" rtl="0" algn="l">
-              <a:spcBef>
-                <a:spcPts val="0"/>
-              </a:spcBef>
-              <a:spcAft>
-                <a:spcPts val="0"/>
-              </a:spcAft>
-              <a:buNone/>
-            </a:pPr>
-            <a:r>
-              <a:rPr b="0" lang="en" sz="1200">
-                <a:solidFill>
-                  <a:srgbClr val="CBD1DA"/>
-                </a:solidFill>
-                <a:latin typeface="DM Sans Medium"/>
-                <a:ea typeface="DM Sans Medium"/>
-                <a:cs typeface="DM Sans Medium"/>
-                <a:sym typeface="DM Sans Medium"/>
-              </a:rPr>
-              <a:t>B · Fill with Formly</a:t>
-            </a:r>
-            <a:endParaRPr b="0" sz="900">
-              <a:solidFill>
-                <a:srgbClr val="CBD1DA"/>
-              </a:solidFill>
-              <a:latin typeface="DM Sans Medium"/>
-              <a:ea typeface="DM Sans Medium"/>
-              <a:cs typeface="DM Sans Medium"/>
-              <a:sym typeface="DM Sans Medium"/>
-            </a:endParaRPr>
-          </a:p>
-        </p:txBody>
-      </p:sp>
-      <p:sp>
-        <p:nvSpPr>
-          <p:cNvPr id="193" name="Google Shape;193;p19"/>
-          <p:cNvSpPr/>
-          <p:nvPr/>
-        </p:nvSpPr>
-        <p:spPr>
-          <a:xfrm>
-            <a:off x="4732020" y="3394710"/>
-            <a:ext cx="3977700" cy="822900"/>
-          </a:xfrm>
-          <a:prstGeom prst="roundRect">
-            <a:avLst>
-              <a:gd fmla="val 16667" name="adj"/>
-            </a:avLst>
-          </a:prstGeom>
-          <a:solidFill>
-            <a:srgbClr val="22C985"/>
-          </a:solidFill>
-          <a:ln cap="flat" cmpd="sng" w="25400">
-            <a:solidFill>
-              <a:srgbClr val="22C985"/>
-            </a:solidFill>
-            <a:prstDash val="solid"/>
-            <a:round/>
-            <a:headEnd len="sm" w="sm" type="none"/>
-            <a:tailEnd len="sm" w="sm" type="none"/>
-          </a:ln>
-        </p:spPr>
-        <p:txBody>
-          <a:bodyPr anchorCtr="0" anchor="ctr" bIns="91425" lIns="91425" spcFirstLastPara="1" rIns="91425" wrap="square" tIns="91425">
-            <a:noAutofit/>
-          </a:bodyPr>
-          <a:lstStyle/>
-          <a:p>
-            <a:pPr indent="0" lvl="0" marL="0" rtl="0" algn="ctr">
-              <a:spcBef>
-                <a:spcPts val="0"/>
-              </a:spcBef>
-              <a:spcAft>
-                <a:spcPts val="0"/>
-              </a:spcAft>
-              <a:buNone/>
-            </a:pPr>
-            <a:r>
-              <a:t/>
-            </a:r>
-            <a:endParaRPr/>
-          </a:p>
-        </p:txBody>
-      </p:sp>
-      <p:sp>
-        <p:nvSpPr>
-          <p:cNvPr id="194" name="Google Shape;194;p19"/>
-          <p:cNvSpPr txBox="1"/>
-          <p:nvPr/>
-        </p:nvSpPr>
-        <p:spPr>
-          <a:xfrm>
-            <a:off x="4640580" y="3394710"/>
-            <a:ext cx="4160400" cy="822900"/>
-          </a:xfrm>
-          <a:prstGeom prst="rect">
-            <a:avLst/>
-          </a:prstGeom>
-          <a:noFill/>
-          <a:ln>
-            <a:noFill/>
-          </a:ln>
-        </p:spPr>
-        <p:txBody>
-          <a:bodyPr anchorCtr="0" anchor="ctr" bIns="91425" lIns="91425" spcFirstLastPara="1" rIns="91425" wrap="square" tIns="91425">
-            <a:noAutofit/>
-          </a:bodyPr>
-          <a:lstStyle/>
-          <a:p>
-            <a:pPr indent="0" lvl="0" marL="0" rtl="0" algn="ctr">
-              <a:spcBef>
-                <a:spcPts val="0"/>
-              </a:spcBef>
-              <a:spcAft>
-                <a:spcPts val="0"/>
-              </a:spcAft>
-              <a:buNone/>
-            </a:pPr>
-            <a:r>
-              <a:rPr lang="en" sz="3300" b="0">
-                <a:solidFill>
-                  <a:srgbClr val="0F1A2A"/>
-                </a:solidFill>
-                <a:latin typeface="Sora SemiBold"/>
-                <a:ea typeface="Sora SemiBold"/>
-                <a:cs typeface="Sora SemiBold"/>
-                <a:sym typeface="Sora SemiBold"/>
-              </a:rPr>
-              <a:t>[m:ss]</a:t>
-            </a:r>
-            <a:endParaRPr sz="3300" b="0">
-              <a:solidFill>
-                <a:srgbClr val="22C985"/>
-              </a:solidFill>
-              <a:latin typeface="Sora SemiBold"/>
-              <a:ea typeface="Sora SemiBold"/>
-              <a:cs typeface="Sora SemiBold"/>
-              <a:sym typeface="Sora SemiBold"/>
-            </a:endParaRPr>
-          </a:p>
-        </p:txBody>
-      </p:sp>
-      <p:sp>
-        <p:nvSpPr>
-          <p:cNvPr id="195" name="TextBox 194"/>
-          <p:cNvSpPr txBox="1"/>
-          <p:nvPr/>
-        </p:nvSpPr>
-        <p:spPr>
-          <a:xfrm>
-            <a:off x="320040" y="4318000"/>
-            <a:ext cx="4160520" cy="279400"/>
-          </a:xfrm>
-          <a:prstGeom prst="rect">
-            <a:avLst/>
-          </a:prstGeom>
-          <a:noFill/>
-        </p:spPr>
-        <p:txBody>
-          <a:bodyPr wrap="square" anchor="t" lIns="45720" rIns="45720">
-            <a:spAutoFit/>
-          </a:bodyPr>
-          <a:lstStyle/>
-          <a:p>
-            <a:pPr algn="ctr"/>
-            <a:r>
-              <a:rPr sz="1200" b="0">
-                <a:solidFill>
-                  <a:srgbClr val="8A94A3"/>
-                </a:solidFill>
-                <a:latin typeface="DM Sans"/>
-              </a:rPr>
-              <a:t>[N] fields typed</a:t>
-            </a:r>
-          </a:p>
-        </p:txBody>
-      </p:sp>
-      <p:sp>
-        <p:nvSpPr>
-          <p:cNvPr id="196" name="TextBox 195"/>
-          <p:cNvSpPr txBox="1"/>
-          <p:nvPr/>
-        </p:nvSpPr>
-        <p:spPr>
-          <a:xfrm>
-            <a:off x="4640580" y="4318000"/>
-            <a:ext cx="4160520" cy="279400"/>
-          </a:xfrm>
-          <a:prstGeom prst="rect">
-            <a:avLst/>
-          </a:prstGeom>
-          <a:noFill/>
-        </p:spPr>
-        <p:txBody>
-          <a:bodyPr wrap="square" anchor="t" lIns="45720" rIns="45720">
-            <a:spAutoFit/>
-          </a:bodyPr>
-          <a:lstStyle/>
-          <a:p>
-            <a:pPr algn="ctr"/>
-            <a:r>
-              <a:rPr sz="1200" b="0">
-                <a:solidFill>
-                  <a:srgbClr val="8A94A3"/>
-                </a:solidFill>
-                <a:latin typeface="DM Sans"/>
-              </a:rPr>
-              <a:t>0 fields typed, every answer sourced</a:t>
-            </a:r>
-          </a:p>
-        </p:txBody>
-      </p:sp>
-    </p:spTree>
-  </p:cSld>
-  <p:clrMapOvr>
-    <a:masterClrMapping/>
-  </p:clrMapOvr>
+  <p:transition spd="fast">
+    <p:fade/>
+  </p:transition>
 </p:sld>
 </file>
 

</xml_diff>